<commit_message>
Arreglo en ppt pequeño
</commit_message>
<xml_diff>
--- a/docs/Abandono, saldo y segmentos — Ecommerce Customer.pptx
+++ b/docs/Abandono, saldo y segmentos — Ecommerce Customer.pptx
@@ -4,6 +4,9 @@
   <p:sldMasterIdLst>
     <p:sldMasterId id="2147483648" r:id="rId1"/>
   </p:sldMasterIdLst>
+  <p:notesMasterIdLst>
+    <p:notesMasterId r:id="rId14"/>
+  </p:notesMasterIdLst>
   <p:sldIdLst>
     <p:sldId id="256" r:id="rId2"/>
     <p:sldId id="257" r:id="rId3"/>
@@ -18,9 +21,6 @@
     <p:sldId id="266" r:id="rId12"/>
     <p:sldId id="267" r:id="rId13"/>
   </p:sldIdLst>
-  <p:notesMasterIdLst>
-    <p:notesMasterId r:id="rId14"/>
-  </p:notesMasterIdLst>
   <p:sldSz cx="12192000" cy="6858000"/>
   <p:notesSz cx="6858000" cy="12192000"/>
   <p:defaultTextStyle>
@@ -115,6 +115,11 @@
       </a:defRPr>
     </a:lvl9pPr>
   </p:defaultTextStyle>
+  <p:extLst>
+    <p:ext uri="{EFAFB233-063F-42B5-8137-9DF3F51BA10A}">
+      <p15:sldGuideLst xmlns:p15="http://schemas.microsoft.com/office/powerpoint/2012/main"/>
+    </p:ext>
+  </p:extLst>
 </p:presentation>
 </file>
 
@@ -140,234 +145,10 @@
           <a:chExt cx="0" cy="0"/>
         </a:xfrm>
       </p:grpSpPr>
-      <p:sp>
-        <p:nvSpPr>
-          <p:cNvPr id="2" name="Header Placeholder 1"/>
-          <p:cNvSpPr>
-            <a:spLocks noGrp="1"/>
-          </p:cNvSpPr>
-          <p:nvPr>
-            <p:ph type="hdr" sz="quarter"/>
-          </p:nvPr>
-        </p:nvSpPr>
-        <p:spPr>
-          <a:xfrm>
-            <a:off x="0" y="0"/>
-            <a:ext cx="2971800" cy="458788"/>
-          </a:xfrm>
-          <a:prstGeom prst="rect">
-            <a:avLst/>
-          </a:prstGeom>
-        </p:spPr>
-        <p:txBody>
-          <a:bodyPr vert="horz" lIns="91440" tIns="45720" rIns="91440" bIns="45720" rtlCol="0"/>
-          <a:lstStyle>
-            <a:lvl1pPr algn="l">
-              <a:defRPr sz="1200"/>
-            </a:lvl1pPr>
-          </a:lstStyle>
-          <a:p>
-            <a:endParaRPr lang="en-US"/>
-          </a:p>
-        </p:txBody>
-      </p:sp>
-      <p:sp>
-        <p:nvSpPr>
-          <p:cNvPr id="3" name="Date Placeholder 2"/>
-          <p:cNvSpPr>
-            <a:spLocks noGrp="1"/>
-          </p:cNvSpPr>
-          <p:nvPr>
-            <p:ph type="dt" idx="1"/>
-          </p:nvPr>
-        </p:nvSpPr>
-        <p:spPr>
-          <a:xfrm>
-            <a:off x="3884613" y="0"/>
-            <a:ext cx="2971800" cy="458788"/>
-          </a:xfrm>
-          <a:prstGeom prst="rect">
-            <a:avLst/>
-          </a:prstGeom>
-        </p:spPr>
-        <p:txBody>
-          <a:bodyPr vert="horz" lIns="91440" tIns="45720" rIns="91440" bIns="45720" rtlCol="0"/>
-          <a:lstStyle>
-            <a:lvl1pPr algn="r">
-              <a:defRPr sz="1200"/>
-            </a:lvl1pPr>
-          </a:lstStyle>
-          <a:p>
-            <a:fld id="{5282F153-3F37-0F45-9E97-73ACFA13230C}" type="datetimeFigureOut">
-              <a:rPr lang="en-US"/>
-              <a:t>7/23/19</a:t>
-            </a:fld>
-            <a:endParaRPr lang="en-US"/>
-          </a:p>
-        </p:txBody>
-      </p:sp>
-      <p:sp>
-        <p:nvSpPr>
-          <p:cNvPr id="4" name="Slide Image Placeholder 3"/>
-          <p:cNvSpPr>
-            <a:spLocks noGrp="1" noRot="1" noChangeAspect="1"/>
-          </p:cNvSpPr>
-          <p:nvPr>
-            <p:ph type="sldImg" idx="2"/>
-          </p:nvPr>
-        </p:nvSpPr>
-        <p:spPr>
-          <a:xfrm>
-            <a:off x="685800" y="1143000"/>
-            <a:ext cx="5486400" cy="3086100"/>
-          </a:xfrm>
-          <a:prstGeom prst="rect">
-            <a:avLst/>
-          </a:prstGeom>
-          <a:noFill/>
-          <a:ln w="12700">
-            <a:solidFill>
-              <a:prstClr val="black"/>
-            </a:solidFill>
-          </a:ln>
-        </p:spPr>
-        <p:txBody>
-          <a:bodyPr vert="horz" lIns="91440" tIns="45720" rIns="91440" bIns="45720" rtlCol="0" anchor="ctr"/>
-          <a:lstStyle/>
-          <a:p>
-            <a:endParaRPr lang="en-US"/>
-          </a:p>
-        </p:txBody>
-      </p:sp>
-      <p:sp>
-        <p:nvSpPr>
-          <p:cNvPr id="5" name="Notes Placeholder 4"/>
-          <p:cNvSpPr>
-            <a:spLocks noGrp="1"/>
-          </p:cNvSpPr>
-          <p:nvPr>
-            <p:ph type="body" sz="quarter" idx="3"/>
-          </p:nvPr>
-        </p:nvSpPr>
-        <p:spPr>
-          <a:xfrm>
-            <a:off x="685800" y="4400550"/>
-            <a:ext cx="5486400" cy="3600450"/>
-          </a:xfrm>
-          <a:prstGeom prst="rect">
-            <a:avLst/>
-          </a:prstGeom>
-        </p:spPr>
-        <p:txBody>
-          <a:bodyPr vert="horz" lIns="91440" tIns="45720" rIns="91440" bIns="45720" rtlCol="0"/>
-          <a:lstStyle/>
-          <a:p>
-            <a:pPr lvl="0"/>
-            <a:r>
-              <a:rPr lang="en-US"/>
-              <a:t>Click to edit Master text styles</a:t>
-            </a:r>
-          </a:p>
-          <a:p>
-            <a:pPr lvl="1"/>
-            <a:r>
-              <a:rPr lang="en-US"/>
-              <a:t>Second level</a:t>
-            </a:r>
-          </a:p>
-          <a:p>
-            <a:pPr lvl="2"/>
-            <a:r>
-              <a:rPr lang="en-US"/>
-              <a:t>Third level</a:t>
-            </a:r>
-          </a:p>
-          <a:p>
-            <a:pPr lvl="3"/>
-            <a:r>
-              <a:rPr lang="en-US"/>
-              <a:t>Fourth level</a:t>
-            </a:r>
-          </a:p>
-          <a:p>
-            <a:pPr lvl="4"/>
-            <a:r>
-              <a:rPr lang="en-US"/>
-              <a:t>Fifth level</a:t>
-            </a:r>
-          </a:p>
-        </p:txBody>
-      </p:sp>
-      <p:sp>
-        <p:nvSpPr>
-          <p:cNvPr id="6" name="Footer Placeholder 5"/>
-          <p:cNvSpPr>
-            <a:spLocks noGrp="1"/>
-          </p:cNvSpPr>
-          <p:nvPr>
-            <p:ph type="ftr" sz="quarter" idx="4"/>
-          </p:nvPr>
-        </p:nvSpPr>
-        <p:spPr>
-          <a:xfrm>
-            <a:off x="0" y="8685213"/>
-            <a:ext cx="2971800" cy="458787"/>
-          </a:xfrm>
-          <a:prstGeom prst="rect">
-            <a:avLst/>
-          </a:prstGeom>
-        </p:spPr>
-        <p:txBody>
-          <a:bodyPr vert="horz" lIns="91440" tIns="45720" rIns="91440" bIns="45720" rtlCol="0" anchor="b"/>
-          <a:lstStyle>
-            <a:lvl1pPr algn="l">
-              <a:defRPr sz="1200"/>
-            </a:lvl1pPr>
-          </a:lstStyle>
-          <a:p>
-            <a:endParaRPr lang="en-US"/>
-          </a:p>
-        </p:txBody>
-      </p:sp>
-      <p:sp>
-        <p:nvSpPr>
-          <p:cNvPr id="7" name="Slide Number Placeholder 6"/>
-          <p:cNvSpPr>
-            <a:spLocks noGrp="1"/>
-          </p:cNvSpPr>
-          <p:nvPr>
-            <p:ph type="sldNum" sz="quarter" idx="5"/>
-          </p:nvPr>
-        </p:nvSpPr>
-        <p:spPr>
-          <a:xfrm>
-            <a:off x="3884613" y="8685213"/>
-            <a:ext cx="2971800" cy="458787"/>
-          </a:xfrm>
-          <a:prstGeom prst="rect">
-            <a:avLst/>
-          </a:prstGeom>
-        </p:spPr>
-        <p:txBody>
-          <a:bodyPr vert="horz" lIns="91440" tIns="45720" rIns="91440" bIns="45720" rtlCol="0" anchor="b"/>
-          <a:lstStyle>
-            <a:lvl1pPr algn="r">
-              <a:defRPr sz="1200"/>
-            </a:lvl1pPr>
-          </a:lstStyle>
-          <a:p>
-            <a:fld id="{CE5E9CC1-C706-0F49-92D6-E571CC5EEA8F}" type="slidenum">
-              <a:rPr lang="en-US"/>
-              <a:t>‹#›</a:t>
-            </a:fld>
-            <a:endParaRPr lang="en-US"/>
-          </a:p>
-        </p:txBody>
-      </p:sp>
     </p:spTree>
     <p:extLst>
       <p:ext uri="{BB962C8B-B14F-4D97-AF65-F5344CB8AC3E}">
-        <p14:creationId xmlns:p14="http://schemas.microsoft.com/office/powerpoint/2010/main" val="1024086991"/>
+        <p14:creationId xmlns:p14="http://schemas.microsoft.com/office/powerpoint/2010/main" val="830538234"/>
       </p:ext>
     </p:extLst>
   </p:cSld>
@@ -515,7 +296,6 @@
               <a:rPr lang="en-US" dirty="0"/>
               <a:t>Abrir con la idea central, antes de cualquier gráfico: con este dataset se puede anticipar razonablemente quién va a abandonar (ROC-AUC 0,86 en prueba), pero el saldo de un cliente prácticamente no se puede proyectar, y buena parte de lo que parecía predecible venía de un sesgo de muestreo. La presentación sigue el orden CRISP-DM de los notebooks: auditoría y EDA, preparación, modelos supervisados y, al final, la segmentación con K-Means. Duración objetivo: ~10 minutos, menos de 1 minuto por lámina.</a:t>
             </a:r>
-            <a:endParaRPr lang="en-US" dirty="0"/>
           </a:p>
         </p:txBody>
       </p:sp>
@@ -603,7 +383,6 @@
               <a:rPr lang="en-US" dirty="0"/>
               <a:t>Aquí vuelve el sesgo de la lámina 3. Balance tiene distribución inflada en cero (36,2% exactamente 0; el resto ~normal en torno a 120.000), y la variable más relacionada es Geography_Germany (r = 0,40). Diseño: cada modelo se evalúa con y sin Geography; el RF se ajusta por separado en cada versión (RandomizedSearchCV, KFold de 5). Líneas base: la mediana para el MAE (54.499 en CV) y el promedio para RMSE y R² (R² = 0). Usar el promedio como referencia del MAE habría exagerado la mejora. Resultados CV: RF con país R² 0,320 (MAE 41.321); sin país 0,132. Lineal 0,281 → 0,134. En prueba: RF con país R² 0,327, MAE 41.230; sin país R² 0,132, MAE 50.446. R² por grupo en prueba (RF con país): Alemania −0,008 (no sabe qué alemán tiene más saldo, solo que en promedio tienen), Francia/España 0,207. Sin país, Alemania cae a −3,40. De ahí la estimación honesta: 13–21%. Lo que realmente aprende: a clientes con saldo 0 les predice en promedio ~47.000 y a los que tienen ~121.000 les predice ~93.000. Correlación predicción–real: 0,57 en total, −0,02 entre los que tienen saldo. El R² mide la separación entre saldo 0 y saldo positivo, no la estimación de montos. Conclusión: el objetivo de la guía (proyectar el volumen de fondos de un cliente) no se puede cumplir con estas variables. Propuesta para seguir (no está implementada en el repo): un modelo en dos partes, clasificador de "tiene saldo" + regresión del monto solo en quienes tienen.</a:t>
             </a:r>
-            <a:endParaRPr lang="en-US" dirty="0"/>
           </a:p>
         </p:txBody>
       </p:sp>
@@ -691,7 +470,6 @@
               <a:rPr lang="en-US" dirty="0"/>
               <a:t>Actividad 2.3.2, no supervisada. Variables: CreditScore, Age, Tenure, Balance, NumOfProducts y EstimatedSalary, escaladas con StandardScaler. Se excluyen identificadores, categóricas (Geography, Gender: distancia sin sentido), binarias (dominarían la distancia) y Exited (se usa solo para describir los grupos después). Elección de K: la inercia no tiene un codo marcado; la mayor caída es de 1 a 2 (−10.145) y luego −4.857, −3.980, −2.928. K = 2 tiene el mayor Silhouette (0,179), pero solo separa con/sin saldo, algo ya conocido. Entre 3 y 10, K = 4 es el mayor (0,170). Con K = 3 los tres grupos tienen 38–40 años de promedio; K = 4 separa además a los mayores. El abandono no se usó para elegir K. Robustez: con n_init = 10, las semillas 1, 2 y 3 llegan a particiones distintas (ARI 0,44–0,46) con inercia apenas mayor (&lt;0,5%): hay varias soluciones casi igual de buenas. Con 300 inicializaciones las 5 semillas coinciden (ARI ≥ 0,996). PCA a 2 componentes conserva 38,7% de la varianza (21,9 + 16,9): solo el grupo sin saldo se ve separado. Perfiles: Senior 59 años, saldo medio ~77.100, 64% activos, 45,4% abandono. Con saldo 1 producto: ~121.000, 20,7%. Con saldo 2+ productos: ~121.000, 20,6%, y es 52,6% alemán (efecto del sesgo: en Francia/España quien tiene 2 productos suele no tener saldo). Sin saldo: 98% en 0, 9,8% abandono. Puntaje, salario y antigüedad no diferencian a ningún segmento. Desafío ético: el producto de inversión va a "Con saldo, 1 producto" (tiene fondos, amplía una relación de un solo producto, y es el segmento más grande y menos afectado por el sesgo). No a Sin saldo (riesgo de endeudamiento), no a Senior como blanco masivo (usar la inversión como gancho de retención con personas mayores exige especial cuidado), no a 2+ productos de forma masiva (3 o más productos se asocia a 82–100% de abandono).</a:t>
             </a:r>
-            <a:endParaRPr lang="en-US" dirty="0"/>
           </a:p>
         </p:txBody>
       </p:sp>
@@ -779,7 +557,6 @@
               <a:rPr lang="en-US" dirty="0"/>
               <a:t>Cerrar volviendo a la idea de la portada. 1) Clasificación: problema bien resuelto con un pipeline sin fugas; la diferencia entre modelos es real pero chica, y lo que define el resultado operativo es el umbral. 2) Regresión: el resultado negativo también es un resultado. Medir con y sin país evitó reportar un R² de 0,33 que en realidad dependía de un artefacto de muestreo. 3) Clustering: sin usar la etiqueta, aparecen las mismas variables que el EDA marcó (edad, saldo, productos). Limitaciones a reconocer antes de que las pregunten: - Sesgo de Alemania: no corregible con estos datos. - Fuga temporal posible en NumOfProducts e IsActiveMember: si se confirmara, las métricas de clasificación serían optimistas. - Centro de la edad calculado con todo el entrenamiento en la CV: CV levemente optimista (la prueba no se afecta). - Umbral elegido por F1 a falta de costos. - Importancia por impureza, no por permutación. - Gender (mujeres 25,1% vs hombres 16,5%) se usa como predictor: puede implicar trato diferenciado. Nota: el modelo en dos partes para el saldo es una propuesta de trabajo futuro, no algo implementado en el repositorio.</a:t>
             </a:r>
-            <a:endParaRPr lang="en-US" dirty="0"/>
           </a:p>
         </p:txBody>
       </p:sp>
@@ -867,7 +644,6 @@
               <a:rPr lang="en-US" dirty="0"/>
               <a:t>Esta es la respuesta completa en una lámina; el resto la respalda. 1) Clasificación de Exited: Random Forest, ROC-AUC 0,862 y PR-AUC 0,703 en prueba (azar = 0,204). Con umbral 0,35: recall 0,60, precisión 0,65, F1 0,62. 2) Regresión de Balance: R² de 0,33 en prueba, pero sin la variable país cae a 0,13; en Francia/España el modelo con país explica 0,21. De ahí el rango honesto de 13–21%. 3) Clustering: K-Means con K = 4 sobre 6 variables numéricas escaladas. El segmento Senior (edad promedio 59) abandona 45,4%. Mensaje: la misma base de datos da un problema bien resuelto, uno que no se puede resolver con estas variables, y una segmentación que confirma el EDA sin usar la etiqueta.</a:t>
             </a:r>
-            <a:endParaRPr lang="en-US" dirty="0"/>
           </a:p>
         </p:txBody>
       </p:sp>
@@ -955,7 +731,6 @@
               <a:rPr lang="en-US" dirty="0"/>
               <a:t>Antes de modelar, la auditoría revisó duplicados, nulos, rangos y outliers (todo limpio) y puso a prueba cada patrón demasiado limpio para ser natural. Hallazgo clave: Francia y España tienen ~48% de clientes con saldo 0; Alemania, ninguno (saldo mínimo 27.288). Entre los clientes con saldo, el promedio es el mismo en los tres países (~120.000), así que no es que los alemanes tengan más dinero. Lo más plausible es que de Alemania solo se incluyeran clientes con saldo. No se puede corregir eliminando filas: se documenta y se mide su efecto en la regresión (lámina 10). Alemania además abandona más (32,4% vs ~16,5%), y esa diferencia se mantiene al comparar clientes parecidos (1,6 a 2,2 veces más dentro de cada grupo de edad, actividad y productos), por eso sí se usa como predictor en clasificación, con la duda documentada. Fuga temporal: el dataset es una foto sin fechas. Si NumOfProducts o IsActiveMember se registraron después del abandono, las métricas de clasificación serían optimistas. Se conservan porque son muy informativas, pero queda como limitación.</a:t>
             </a:r>
-            <a:endParaRPr lang="en-US" dirty="0"/>
           </a:p>
         </p:txBody>
       </p:sp>
@@ -1043,7 +818,6 @@
               <a:rPr lang="en-US" dirty="0"/>
               <a:t>La relación no es ordinal: 27,7% con 1 producto, 7,6% con 2, 82,7% con 3 y 100% con 4. Pasar de 1 a 2 reduce el abandono a menos de un tercio; pasar a 3 lo multiplica por 11. Por eso la correlación de Pearson con Exited es -0,05: el efecto negativo de 2 productos (r = -0,29 en la columna one-hot) y el positivo de 3 (r = +0,26) se cancelan cuando la variable se trata como número. Implicancia: one-hot con drop='first'. Los grupos de 3 y 4 productos son chicos (326 clientes, 3,3% de la cartera), así que son un grupo de riesgo casi seguro, pero también el principal sospechoso de fuga temporal (lámina anterior). Si preguntan por el desbalance: 20,4% de abandono, por eso la partición es estratificada y no se usa accuracy como métrica principal (predecir siempre "se mantiene" da 79,6%).</a:t>
             </a:r>
-            <a:endParaRPr lang="en-US" dirty="0"/>
           </a:p>
         </p:txBody>
       </p:sp>
@@ -1131,7 +905,6 @@
               <a:rPr lang="en-US" dirty="0"/>
               <a:t>El abandono sube de 7,5% (18–30) a 56,2% (51–60) y vuelve a caer: 31,4% entre 61 y 70 y 8,3% sobre 70. Una relación así no la captura bien un término lineal en Age. Solución: distancia_edad_riesgo = |Age − centro|. Se barrieron centros entre 40 y 65 y se eligió el que maximiza |r| con Exited. En el EDA dio ~54–56 con los 10.000 clientes; como el centro se elige mirando el target, es un parámetro aprendido, así que en preprocesamiento se recalcula solo con el entrenamiento: vuelve a dar 55. r pasa de +0,28 (Age) a −0,36 (distancia). Age y la distancia correlacionan −0,82, bajo el umbral de 0,9 del filtro: se conservan ambas. Matiz honesto: en la validación cruzada de modelamiento ese centro se calculó con todo el entrenamiento (incluida la parte de validación de cada partición). Es un solo número y coincide con el del EDA, pero deja la CV levemente optimista; la prueba no se ve afectada. Los outliers de Age (3,59% sobre ~62 años) no se recortan: son justamente los que abandonan menos, y un winsorizer los fusionaría con el grupo de mayor riesgo. Interacción: 18–40 años, inactivo 13,5% vs activo 7,9%; sobre 60, 82,0% vs 11,2% (solo 89 inactivos mayores de 60: la cifra exacta es menos precisa que la tendencia).</a:t>
             </a:r>
-            <a:endParaRPr lang="en-US" dirty="0"/>
           </a:p>
         </p:txBody>
       </p:sp>
@@ -1219,7 +992,6 @@
               <a:rPr lang="en-US" dirty="0"/>
               <a:t>El hilo de esta lámina es evitar data leakage en cada paso. - Partición antes de ajustar cualquier transformador. Una sola partición 80/20 estratificada (8.000 / 2.000), reutilizada para clasificación y regresión. - Imputación por mediana aunque no hay nulos: deja el pipeline seguro ante datos nuevos; mediana porque Balance es bimodal (36% en 0) y su media no representa a ningún cliente real. - drop='first' evita la trampa de las dummies en la regresión lineal. Combinado con handle_unknown='ignore' sería peligroso: un país nuevo quedaría codificado igual que la categoría eliminada (Francia), sin aviso. Por eso 'error'; se comprobó con un cliente ficticio de Italia: el pipeline se detiene. - CorrelationFilter (BaseEstimator + TransformerMixin) aprende en fit qué columnas eliminar. Descartó tiene_saldo en clasificación (r = 0,92 con Balance); en regresión no descarta nada. - Regresión: se excluyen Balance, tiene_saldo (derivada del target) y Exited (posterior al saldo). Búsqueda: el escalado, el one-hot y el filtro se reajustan dentro de cada partición. GridSearch para la logística porque el espacio es chico; RandomizedSearch para el Random Forest porque son miles de combinaciones. refit='PR-AUC' por ser la métrica más informativa con clases desbalanceadas. Resultado de la búsqueda: logística C = 10, l1 (pero C = 1 ya daba lo mismo al cuarto decimal); RF 513 árboles, max_depth 10, min_samples_leaf 1, max_features 'sqrt'. Las 30 combinaciones del RF quedan entre 0,663 y 0,684 de PR-AUC: es poco sensible a sus hiperparámetros.</a:t>
             </a:r>
-            <a:endParaRPr lang="en-US" dirty="0"/>
           </a:p>
         </p:txBody>
       </p:sp>
@@ -1307,7 +1079,6 @@
               <a:rPr lang="en-US" dirty="0"/>
               <a:t>Los dos modelos se evalúan con las mismas 5 particiones, lo que permite una comparación pareada: restar los puntajes en cada partición. Por qué no basta con mirar media ± desviación: la desviación entre particiones (0,012–0,023) mide sobre todo qué tan difícil le tocó cada partición, y esa dificultad la comparten ambos modelos. La diferencia pareada es positiva en las 5 particiones. Por qué la corrección de Nadeau y Bengio (2003): las 5 particiones comparten gran parte del entrenamiento, así que los puntajes no son independientes y la t clásica exageraría la confianza. Con la corrección: t = 3,72, p = 0,020 (ROC-AUC); t = 2,98, p = 0,041 (PR-AUC). Cautela: la ventaja puede estar algo inflada, porque el RF se eligió entre 30 combinaciones y la logística entre 12 (la mejor de muchas queda un poco sobre lo que logrará con datos nuevos). La prueba (lámina 9) lo confirma: 0,862 vs 0,850. La logística sigue siendo razonable si se prioriza explicar cada predicción. Con el mismo recall, el RF tiene más precisión en todos los niveles (0,5 a 2,1 puntos entre recall 0,60 y 0,80).</a:t>
             </a:r>
-            <a:endParaRPr lang="en-US" dirty="0"/>
           </a:p>
         </p:txBody>
       </p:sp>
@@ -1395,7 +1166,6 @@
               <a:rPr lang="en-US" dirty="0"/>
               <a:t>Decisión técnica central del notebook: el desbalance (20,4%) no se corrige con class_weight='balanced' sino con el umbral. Calibración (predicciones fuera de pliegue): sin class_weight, la probabilidad media es 0,204 (logística) y 0,203 (RF), igual a la tasa real. Con 'balanced' sube a 0,391 y 0,318, el Brier empeora (0,108 → 0,155 y 0,105 → 0,124) y el ROC-AUC no mejora (0,848 → 0,848; 0,858 → 0,854). Es decir, class_weight solo desplaza las probabilidades hacia arriba, que es equivalente a bajar el umbral, pero se pierde la interpretación probabilística. El umbral se elige con predicciones out-of-fold sobre el entrenamiento, maximizando F1 en pasos de 0,05: 0,35 para el RF (0,30 para la logística). F1 es casi plano entre 0,25 y 0,35 (0,608–0,615), así que dentro de ese rango manda el negocio. Lectura de la tabla: con 0,20 se detecta el 76% de los abandonos, pero se alerta a un tercio de la cartera y menos de la mitad de las alertas son reales; con 0,50, 78% de las alertas son reales pero solo se detecta el 44%. Si se conocieran los costos (perder un cliente vs una acción de retención), se minimizaría el costo esperado en vez de maximizar F1; scikit-learn 1.5+ trae TunedThresholdClassifierCV para eso.</a:t>
             </a:r>
-            <a:endParaRPr lang="en-US" dirty="0"/>
           </a:p>
         </p:txBody>
       </p:sp>
@@ -1483,7 +1253,6 @@
               <a:rPr lang="en-US" dirty="0"/>
               <a:t>Con hiperparámetros, modelo y umbral ya decididos en validación cruzada, la prueba se usa una sola vez. Random Forest (umbral 0,35): ROC-AUC 0,862, PR-AUC 0,703, Brier 0,103, accuracy 0,851, precisión 0,645, recall 0,595, F1 0,619. Logística (umbral 0,30): ROC-AUC 0,850, PR-AUC 0,684, Brier 0,106, accuracy 0,827, precisión 0,565, recall 0,654, F1 0,606. Las métricas de prueba quedan dentro del rango de la CV (PR-AUC 0,703 vs 0,684 ± 0,023): no hay señales de sobreajuste ni de que la búsqueda de hiperparámetros haya inflado la validación. Matriz de confusión del RF: 242 VP, 165 FN, 133 FP, 1.460 VN. La logística detecta 24 abandonos más (266) a cambio de 72 falsas alarmas más (205): es consecuencia de que cada umbral se eligió por F1, no de que sea mejor modelo. Referencia: predecir siempre "se mantiene" da accuracy 0,796 y recall 0. Importancia de variables (si preguntan): distancia_edad_riesgo, Age, NumOfProducts_2, Balance y NumOfProducts_3 son las más usadas, coherente con el EDA. Ojo: es importancia por impureza, que favorece variables continuas con muchos valores; por eso CreditScore y EstimatedSalary aparecen sobre IsActiveMember aunque el EDA mostró que no cambian el abandono. La importancia por permutación sería la verificación natural.</a:t>
             </a:r>
-            <a:endParaRPr lang="en-US" dirty="0"/>
           </a:p>
         </p:txBody>
       </p:sp>
@@ -1561,6 +1330,7 @@
         <a:solidFill>
           <a:srgbClr val="F6F5F1"/>
         </a:solidFill>
+        <a:effectLst/>
       </p:bgPr>
     </p:bg>
     <p:spTree>
@@ -1580,7 +1350,9 @@
       <p:sp>
         <p:nvSpPr>
           <p:cNvPr id="2" name="Title Placeholder 1"/>
-          <p:cNvSpPr/>
+          <p:cNvSpPr>
+            <a:spLocks noGrp="1"/>
+          </p:cNvSpPr>
           <p:nvPr>
             <p:ph type="title"/>
           </p:nvPr>
@@ -1599,7 +1371,7 @@
         <p:txBody>
           <a:bodyPr wrap="square" lIns="0" tIns="0" rIns="0" bIns="0" rtlCol="0" anchor="t"/>
           <a:lstStyle>
-            <a:lvl1pPr algn="l" indent="0" marL="0">
+            <a:lvl1pPr marL="0" indent="0" algn="l">
               <a:lnSpc>
                 <a:spcPct val="115000"/>
               </a:lnSpc>
@@ -1615,7 +1387,7 @@
             </a:lvl1pPr>
           </a:lstStyle>
           <a:p>
-            <a:pPr algn="l" indent="0" marL="0">
+            <a:pPr marL="0" indent="0" algn="l">
               <a:lnSpc>
                 <a:spcPct val="115000"/>
               </a:lnSpc>
@@ -1628,9 +1400,11 @@
       <p:sp>
         <p:nvSpPr>
           <p:cNvPr id="3" name="Text Placeholder 2"/>
-          <p:cNvSpPr/>
+          <p:cNvSpPr>
+            <a:spLocks noGrp="1"/>
+          </p:cNvSpPr>
           <p:nvPr>
-            <p:ph idx="101" type="body"/>
+            <p:ph type="body" idx="101"/>
           </p:nvPr>
         </p:nvSpPr>
         <p:spPr>
@@ -1647,7 +1421,7 @@
         <p:txBody>
           <a:bodyPr wrap="square" lIns="0" tIns="0" rIns="0" bIns="0" rtlCol="0" anchor="t"/>
           <a:lstStyle>
-            <a:lvl1pPr algn="l" indent="0" marL="0">
+            <a:lvl1pPr marL="0" indent="0" algn="l">
               <a:lnSpc>
                 <a:spcPct val="140000"/>
               </a:lnSpc>
@@ -1663,7 +1437,7 @@
             </a:lvl1pPr>
           </a:lstStyle>
           <a:p>
-            <a:pPr algn="l" indent="0" marL="0">
+            <a:pPr marL="0" indent="0" algn="l">
               <a:lnSpc>
                 <a:spcPct val="140000"/>
               </a:lnSpc>
@@ -1689,6 +1463,7 @@
         <a:solidFill>
           <a:srgbClr val="F6F5F1"/>
         </a:solidFill>
+        <a:effectLst/>
       </p:bgPr>
     </p:bg>
     <p:spTree>
@@ -1974,6 +1749,7 @@
         <a:solidFill>
           <a:srgbClr val="1C2230"/>
         </a:solidFill>
+        <a:effectLst/>
       </p:bgPr>
     </p:bg>
     <p:spTree>
@@ -2013,14 +1789,14 @@
           </a:bodyPr>
           <a:lstStyle/>
           <a:p>
-            <a:pPr algn="l" indent="0" marL="0">
+            <a:pPr marL="0" indent="0" algn="l">
               <a:lnSpc>
                 <a:spcPts val="1680"/>
               </a:lnSpc>
               <a:buNone/>
             </a:pPr>
             <a:r>
-              <a:rPr lang="en-US" sz="1200" b="1" spc="100" kern="0" dirty="0">
+              <a:rPr lang="en-US" sz="1200" b="1" kern="0" spc="100" dirty="0">
                 <a:solidFill>
                   <a:srgbClr val="F08A4B"/>
                 </a:solidFill>
@@ -2037,7 +1813,9 @@
       <p:sp>
         <p:nvSpPr>
           <p:cNvPr id="3" name="Text 1"/>
-          <p:cNvSpPr/>
+          <p:cNvSpPr>
+            <a:spLocks noGrp="1"/>
+          </p:cNvSpPr>
           <p:nvPr>
             <p:ph type="title"/>
           </p:nvPr>
@@ -2059,7 +1837,7 @@
           </a:bodyPr>
           <a:lstStyle/>
           <a:p>
-            <a:pPr algn="l" indent="0" marL="0">
+            <a:pPr marL="0" indent="0" algn="l">
               <a:lnSpc>
                 <a:spcPts val="4840"/>
               </a:lnSpc>
@@ -2079,7 +1857,7 @@
             <a:endParaRPr lang="en-US" sz="4400" dirty="0"/>
           </a:p>
           <a:p>
-            <a:pPr algn="l" indent="0" marL="0">
+            <a:pPr marL="0" indent="0" algn="l">
               <a:lnSpc>
                 <a:spcPts val="4840"/>
               </a:lnSpc>
@@ -2123,7 +1901,7 @@
           </a:bodyPr>
           <a:lstStyle/>
           <a:p>
-            <a:pPr algn="l" indent="0" marL="0">
+            <a:pPr marL="0" indent="0" algn="l">
               <a:lnSpc>
                 <a:spcPts val="2100"/>
               </a:lnSpc>
@@ -2167,7 +1945,7 @@
           </a:bodyPr>
           <a:lstStyle/>
           <a:p>
-            <a:pPr algn="l" indent="0" marL="0">
+            <a:pPr marL="0" indent="0" algn="l">
               <a:lnSpc>
                 <a:spcPts val="1680"/>
               </a:lnSpc>
@@ -2182,7 +1960,7 @@
                 <a:ea typeface="IBM Plex Sans" pitchFamily="34" charset="-122"/>
                 <a:cs typeface="IBM Plex Sans" pitchFamily="34" charset="-120"/>
               </a:rPr>
-              <a:t>Felipe Ahumada · Laboratorio 2.2.2 y actividad 2.3.2</a:t>
+              <a:t>Felipe Ahumada Silva – Francisca Carrasco Lozano · Laboratorio 2.2.2 y actividad 2.3.2</a:t>
             </a:r>
             <a:endParaRPr lang="en-US" sz="1200" dirty="0"/>
           </a:p>
@@ -2204,6 +1982,7 @@
         <a:solidFill>
           <a:srgbClr val="F6F5F1"/>
         </a:solidFill>
+        <a:effectLst/>
       </p:bgPr>
     </p:bg>
     <p:spTree>
@@ -2243,14 +2022,14 @@
           </a:bodyPr>
           <a:lstStyle/>
           <a:p>
-            <a:pPr algn="l" indent="0" marL="0">
+            <a:pPr marL="0" indent="0" algn="l">
               <a:lnSpc>
                 <a:spcPts val="1680"/>
               </a:lnSpc>
               <a:buNone/>
             </a:pPr>
             <a:r>
-              <a:rPr lang="en-US" sz="1200" b="1" spc="100" kern="0" dirty="0">
+              <a:rPr lang="en-US" sz="1200" b="1" kern="0" spc="100" dirty="0">
                 <a:solidFill>
                   <a:srgbClr val="B34A18"/>
                 </a:solidFill>
@@ -2267,7 +2046,9 @@
       <p:sp>
         <p:nvSpPr>
           <p:cNvPr id="3" name="Text 1"/>
-          <p:cNvSpPr/>
+          <p:cNvSpPr>
+            <a:spLocks noGrp="1"/>
+          </p:cNvSpPr>
           <p:nvPr>
             <p:ph type="title"/>
           </p:nvPr>
@@ -2289,7 +2070,7 @@
           </a:bodyPr>
           <a:lstStyle/>
           <a:p>
-            <a:pPr algn="l" indent="0" marL="0">
+            <a:pPr marL="0" indent="0" algn="l">
               <a:lnSpc>
                 <a:spcPts val="3520"/>
               </a:lnSpc>
@@ -2333,7 +2114,7 @@
           </a:bodyPr>
           <a:lstStyle/>
           <a:p>
-            <a:pPr algn="l" indent="0" marL="0">
+            <a:pPr marL="0" indent="0" algn="l">
               <a:lnSpc>
                 <a:spcPts val="1680"/>
               </a:lnSpc>
@@ -2377,7 +2158,7 @@
           </a:bodyPr>
           <a:lstStyle/>
           <a:p>
-            <a:pPr algn="l" indent="0" marL="0">
+            <a:pPr marL="0" indent="0" algn="l">
               <a:lnSpc>
                 <a:spcPts val="1800"/>
               </a:lnSpc>
@@ -2421,7 +2202,7 @@
           </a:bodyPr>
           <a:lstStyle/>
           <a:p>
-            <a:pPr algn="l" indent="0" marL="0">
+            <a:pPr marL="0" indent="0" algn="l">
               <a:lnSpc>
                 <a:spcPts val="1680"/>
               </a:lnSpc>
@@ -2461,6 +2242,13 @@
           </a:solidFill>
           <a:ln/>
         </p:spPr>
+        <p:txBody>
+          <a:bodyPr/>
+          <a:lstStyle/>
+          <a:p>
+            <a:endParaRPr lang="es-CL"/>
+          </a:p>
+        </p:txBody>
       </p:sp>
       <p:sp>
         <p:nvSpPr>
@@ -2485,7 +2273,7 @@
           </a:bodyPr>
           <a:lstStyle/>
           <a:p>
-            <a:pPr algn="l" indent="0" marL="0">
+            <a:pPr marL="0" indent="0" algn="l">
               <a:lnSpc>
                 <a:spcPts val="2100"/>
               </a:lnSpc>
@@ -2529,7 +2317,7 @@
           </a:bodyPr>
           <a:lstStyle/>
           <a:p>
-            <a:pPr algn="l" indent="0" marL="0">
+            <a:pPr marL="0" indent="0" algn="l">
               <a:lnSpc>
                 <a:spcPts val="1680"/>
               </a:lnSpc>
@@ -2569,6 +2357,13 @@
           </a:solidFill>
           <a:ln/>
         </p:spPr>
+        <p:txBody>
+          <a:bodyPr/>
+          <a:lstStyle/>
+          <a:p>
+            <a:endParaRPr lang="es-CL"/>
+          </a:p>
+        </p:txBody>
       </p:sp>
       <p:sp>
         <p:nvSpPr>
@@ -2593,7 +2388,7 @@
           </a:bodyPr>
           <a:lstStyle/>
           <a:p>
-            <a:pPr algn="l" indent="0" marL="0">
+            <a:pPr marL="0" indent="0" algn="l">
               <a:lnSpc>
                 <a:spcPts val="2100"/>
               </a:lnSpc>
@@ -2637,7 +2432,7 @@
           </a:bodyPr>
           <a:lstStyle/>
           <a:p>
-            <a:pPr algn="l" indent="0" marL="0">
+            <a:pPr marL="0" indent="0" algn="l">
               <a:lnSpc>
                 <a:spcPts val="1800"/>
               </a:lnSpc>
@@ -2681,7 +2476,7 @@
           </a:bodyPr>
           <a:lstStyle/>
           <a:p>
-            <a:pPr algn="l" indent="0" marL="0">
+            <a:pPr marL="0" indent="0" algn="l">
               <a:lnSpc>
                 <a:spcPts val="1680"/>
               </a:lnSpc>
@@ -2721,6 +2516,13 @@
           </a:solidFill>
           <a:ln/>
         </p:spPr>
+        <p:txBody>
+          <a:bodyPr/>
+          <a:lstStyle/>
+          <a:p>
+            <a:endParaRPr lang="es-CL"/>
+          </a:p>
+        </p:txBody>
       </p:sp>
       <p:sp>
         <p:nvSpPr>
@@ -2745,7 +2547,7 @@
           </a:bodyPr>
           <a:lstStyle/>
           <a:p>
-            <a:pPr algn="l" indent="0" marL="0">
+            <a:pPr marL="0" indent="0" algn="l">
               <a:lnSpc>
                 <a:spcPts val="2100"/>
               </a:lnSpc>
@@ -2789,7 +2591,7 @@
           </a:bodyPr>
           <a:lstStyle/>
           <a:p>
-            <a:pPr algn="l" indent="0" marL="0">
+            <a:pPr marL="0" indent="0" algn="l">
               <a:lnSpc>
                 <a:spcPts val="1680"/>
               </a:lnSpc>
@@ -2829,6 +2631,13 @@
           </a:solidFill>
           <a:ln/>
         </p:spPr>
+        <p:txBody>
+          <a:bodyPr/>
+          <a:lstStyle/>
+          <a:p>
+            <a:endParaRPr lang="es-CL"/>
+          </a:p>
+        </p:txBody>
       </p:sp>
       <p:sp>
         <p:nvSpPr>
@@ -2853,7 +2662,7 @@
           </a:bodyPr>
           <a:lstStyle/>
           <a:p>
-            <a:pPr algn="l" indent="0" marL="0">
+            <a:pPr marL="0" indent="0" algn="l">
               <a:lnSpc>
                 <a:spcPts val="2100"/>
               </a:lnSpc>
@@ -2897,7 +2706,7 @@
           </a:bodyPr>
           <a:lstStyle/>
           <a:p>
-            <a:pPr algn="l" indent="0" marL="0">
+            <a:pPr marL="0" indent="0" algn="l">
               <a:lnSpc>
                 <a:spcPts val="1680"/>
               </a:lnSpc>
@@ -2941,7 +2750,7 @@
           </a:bodyPr>
           <a:lstStyle/>
           <a:p>
-            <a:pPr algn="l" indent="0" marL="0">
+            <a:pPr marL="0" indent="0" algn="l">
               <a:lnSpc>
                 <a:spcPts val="4840"/>
               </a:lnSpc>
@@ -2985,7 +2794,7 @@
           </a:bodyPr>
           <a:lstStyle/>
           <a:p>
-            <a:pPr algn="l" indent="0" marL="0">
+            <a:pPr marL="0" indent="0" algn="l">
               <a:lnSpc>
                 <a:spcPts val="2100"/>
               </a:lnSpc>
@@ -3051,7 +2860,7 @@
           </a:bodyPr>
           <a:lstStyle/>
           <a:p>
-            <a:pPr algn="l" indent="0" marL="0">
+            <a:pPr marL="0" indent="0" algn="l">
               <a:lnSpc>
                 <a:spcPts val="1680"/>
               </a:lnSpc>
@@ -3095,7 +2904,7 @@
           </a:bodyPr>
           <a:lstStyle/>
           <a:p>
-            <a:pPr algn="l" indent="0" marL="0">
+            <a:pPr marL="0" indent="0" algn="l">
               <a:lnSpc>
                 <a:spcPts val="1680"/>
               </a:lnSpc>
@@ -3139,7 +2948,7 @@
           </a:bodyPr>
           <a:lstStyle/>
           <a:p>
-            <a:pPr algn="r" indent="0" marL="0">
+            <a:pPr marL="0" indent="0" algn="r">
               <a:lnSpc>
                 <a:spcPts val="1680"/>
               </a:lnSpc>
@@ -3176,6 +2985,7 @@
         <a:solidFill>
           <a:srgbClr val="F6F5F1"/>
         </a:solidFill>
+        <a:effectLst/>
       </p:bgPr>
     </p:bg>
     <p:spTree>
@@ -3215,14 +3025,14 @@
           </a:bodyPr>
           <a:lstStyle/>
           <a:p>
-            <a:pPr algn="l" indent="0" marL="0">
+            <a:pPr marL="0" indent="0" algn="l">
               <a:lnSpc>
                 <a:spcPts val="1680"/>
               </a:lnSpc>
               <a:buNone/>
             </a:pPr>
             <a:r>
-              <a:rPr lang="en-US" sz="1200" b="1" spc="100" kern="0" dirty="0">
+              <a:rPr lang="en-US" sz="1200" b="1" kern="0" spc="100" dirty="0">
                 <a:solidFill>
                   <a:srgbClr val="B34A18"/>
                 </a:solidFill>
@@ -3239,7 +3049,9 @@
       <p:sp>
         <p:nvSpPr>
           <p:cNvPr id="3" name="Text 1"/>
-          <p:cNvSpPr/>
+          <p:cNvSpPr>
+            <a:spLocks noGrp="1"/>
+          </p:cNvSpPr>
           <p:nvPr>
             <p:ph type="title"/>
           </p:nvPr>
@@ -3261,7 +3073,7 @@
           </a:bodyPr>
           <a:lstStyle/>
           <a:p>
-            <a:pPr algn="l" indent="0" marL="0">
+            <a:pPr marL="0" indent="0" algn="l">
               <a:lnSpc>
                 <a:spcPts val="3520"/>
               </a:lnSpc>
@@ -3305,7 +3117,7 @@
           </a:bodyPr>
           <a:lstStyle/>
           <a:p>
-            <a:pPr algn="l" indent="0" marL="0">
+            <a:pPr marL="0" indent="0" algn="l">
               <a:lnSpc>
                 <a:spcPts val="1680"/>
               </a:lnSpc>
@@ -3349,7 +3161,7 @@
           </a:bodyPr>
           <a:lstStyle/>
           <a:p>
-            <a:pPr algn="l" indent="0" marL="0">
+            <a:pPr marL="0" indent="0" algn="l">
               <a:lnSpc>
                 <a:spcPts val="2100"/>
               </a:lnSpc>
@@ -3411,6 +3223,13 @@
           </a:solidFill>
           <a:ln/>
         </p:spPr>
+        <p:txBody>
+          <a:bodyPr/>
+          <a:lstStyle/>
+          <a:p>
+            <a:endParaRPr lang="es-CL"/>
+          </a:p>
+        </p:txBody>
       </p:sp>
       <p:sp>
         <p:nvSpPr>
@@ -3435,7 +3254,7 @@
           </a:bodyPr>
           <a:lstStyle/>
           <a:p>
-            <a:pPr algn="l" indent="0" marL="0">
+            <a:pPr marL="0" indent="0" algn="l">
               <a:lnSpc>
                 <a:spcPts val="2100"/>
               </a:lnSpc>
@@ -3479,7 +3298,7 @@
           </a:bodyPr>
           <a:lstStyle/>
           <a:p>
-            <a:pPr algn="l" indent="0" marL="0">
+            <a:pPr marL="0" indent="0" algn="l">
               <a:lnSpc>
                 <a:spcPts val="2100"/>
               </a:lnSpc>
@@ -3541,6 +3360,13 @@
           </a:solidFill>
           <a:ln/>
         </p:spPr>
+        <p:txBody>
+          <a:bodyPr/>
+          <a:lstStyle/>
+          <a:p>
+            <a:endParaRPr lang="es-CL"/>
+          </a:p>
+        </p:txBody>
       </p:sp>
       <p:sp>
         <p:nvSpPr>
@@ -3565,7 +3391,7 @@
           </a:bodyPr>
           <a:lstStyle/>
           <a:p>
-            <a:pPr algn="l" indent="0" marL="0">
+            <a:pPr marL="0" indent="0" algn="l">
               <a:lnSpc>
                 <a:spcPts val="2100"/>
               </a:lnSpc>
@@ -3609,7 +3435,7 @@
           </a:bodyPr>
           <a:lstStyle/>
           <a:p>
-            <a:pPr algn="l" indent="0" marL="0">
+            <a:pPr marL="0" indent="0" algn="l">
               <a:lnSpc>
                 <a:spcPts val="2100"/>
               </a:lnSpc>
@@ -3671,6 +3497,13 @@
           </a:solidFill>
           <a:ln/>
         </p:spPr>
+        <p:txBody>
+          <a:bodyPr/>
+          <a:lstStyle/>
+          <a:p>
+            <a:endParaRPr lang="es-CL"/>
+          </a:p>
+        </p:txBody>
       </p:sp>
       <p:sp>
         <p:nvSpPr>
@@ -3695,7 +3528,7 @@
           </a:bodyPr>
           <a:lstStyle/>
           <a:p>
-            <a:pPr algn="l" indent="0" marL="0">
+            <a:pPr marL="0" indent="0" algn="l">
               <a:lnSpc>
                 <a:spcPts val="2100"/>
               </a:lnSpc>
@@ -3739,7 +3572,7 @@
           </a:bodyPr>
           <a:lstStyle/>
           <a:p>
-            <a:pPr algn="l" indent="0" marL="0">
+            <a:pPr marL="0" indent="0" algn="l">
               <a:lnSpc>
                 <a:spcPts val="2100"/>
               </a:lnSpc>
@@ -3801,6 +3634,13 @@
           </a:solidFill>
           <a:ln/>
         </p:spPr>
+        <p:txBody>
+          <a:bodyPr/>
+          <a:lstStyle/>
+          <a:p>
+            <a:endParaRPr lang="es-CL"/>
+          </a:p>
+        </p:txBody>
       </p:sp>
       <p:sp>
         <p:nvSpPr>
@@ -3825,7 +3665,7 @@
           </a:bodyPr>
           <a:lstStyle/>
           <a:p>
-            <a:pPr algn="l" indent="0" marL="0">
+            <a:pPr marL="0" indent="0" algn="l">
               <a:lnSpc>
                 <a:spcPts val="2100"/>
               </a:lnSpc>
@@ -3869,7 +3709,7 @@
           </a:bodyPr>
           <a:lstStyle/>
           <a:p>
-            <a:pPr algn="l" indent="0" marL="0">
+            <a:pPr marL="0" indent="0" algn="l">
               <a:lnSpc>
                 <a:spcPts val="2100"/>
               </a:lnSpc>
@@ -3913,7 +3753,7 @@
           </a:bodyPr>
           <a:lstStyle/>
           <a:p>
-            <a:pPr algn="l" indent="0" marL="0">
+            <a:pPr marL="0" indent="0" algn="l">
               <a:lnSpc>
                 <a:spcPts val="1680"/>
               </a:lnSpc>
@@ -3957,7 +3797,7 @@
           </a:bodyPr>
           <a:lstStyle/>
           <a:p>
-            <a:pPr algn="l" indent="0" marL="0">
+            <a:pPr marL="0" indent="0" algn="l">
               <a:lnSpc>
                 <a:spcPts val="2100"/>
               </a:lnSpc>
@@ -4001,7 +3841,7 @@
           </a:bodyPr>
           <a:lstStyle/>
           <a:p>
-            <a:pPr algn="l" indent="0" marL="0">
+            <a:pPr marL="0" indent="0" algn="l">
               <a:lnSpc>
                 <a:spcPts val="1680"/>
               </a:lnSpc>
@@ -4045,7 +3885,7 @@
           </a:bodyPr>
           <a:lstStyle/>
           <a:p>
-            <a:pPr algn="l" indent="0" marL="0">
+            <a:pPr marL="0" indent="0" algn="l">
               <a:lnSpc>
                 <a:spcPts val="2100"/>
               </a:lnSpc>
@@ -4089,7 +3929,7 @@
           </a:bodyPr>
           <a:lstStyle/>
           <a:p>
-            <a:pPr algn="l" indent="0" marL="0">
+            <a:pPr marL="0" indent="0" algn="l">
               <a:lnSpc>
                 <a:spcPts val="1680"/>
               </a:lnSpc>
@@ -4132,6 +3972,13 @@
             <a:prstDash val="solid"/>
           </a:ln>
         </p:spPr>
+        <p:txBody>
+          <a:bodyPr/>
+          <a:lstStyle/>
+          <a:p>
+            <a:endParaRPr lang="es-CL"/>
+          </a:p>
+        </p:txBody>
       </p:sp>
       <p:sp>
         <p:nvSpPr>
@@ -4156,7 +4003,7 @@
           </a:bodyPr>
           <a:lstStyle/>
           <a:p>
-            <a:pPr algn="l" indent="0" marL="0">
+            <a:pPr marL="0" indent="0" algn="l">
               <a:lnSpc>
                 <a:spcPts val="1680"/>
               </a:lnSpc>
@@ -4211,7 +4058,7 @@
           </a:bodyPr>
           <a:lstStyle/>
           <a:p>
-            <a:pPr algn="l" indent="0" marL="0">
+            <a:pPr marL="0" indent="0" algn="l">
               <a:lnSpc>
                 <a:spcPts val="1680"/>
               </a:lnSpc>
@@ -4255,7 +4102,7 @@
           </a:bodyPr>
           <a:lstStyle/>
           <a:p>
-            <a:pPr algn="r" indent="0" marL="0">
+            <a:pPr marL="0" indent="0" algn="r">
               <a:lnSpc>
                 <a:spcPts val="1680"/>
               </a:lnSpc>
@@ -4292,6 +4139,7 @@
         <a:solidFill>
           <a:srgbClr val="1C2230"/>
         </a:solidFill>
+        <a:effectLst/>
       </p:bgPr>
     </p:bg>
     <p:spTree>
@@ -4331,14 +4179,14 @@
           </a:bodyPr>
           <a:lstStyle/>
           <a:p>
-            <a:pPr algn="l" indent="0" marL="0">
+            <a:pPr marL="0" indent="0" algn="l">
               <a:lnSpc>
                 <a:spcPts val="1680"/>
               </a:lnSpc>
               <a:buNone/>
             </a:pPr>
             <a:r>
-              <a:rPr lang="en-US" sz="1200" b="1" spc="100" kern="0" dirty="0">
+              <a:rPr lang="en-US" sz="1200" b="1" kern="0" spc="100" dirty="0">
                 <a:solidFill>
                   <a:srgbClr val="F08A4B"/>
                 </a:solidFill>
@@ -4355,7 +4203,9 @@
       <p:sp>
         <p:nvSpPr>
           <p:cNvPr id="3" name="Text 1"/>
-          <p:cNvSpPr/>
+          <p:cNvSpPr>
+            <a:spLocks noGrp="1"/>
+          </p:cNvSpPr>
           <p:nvPr>
             <p:ph type="title"/>
           </p:nvPr>
@@ -4377,7 +4227,7 @@
           </a:bodyPr>
           <a:lstStyle/>
           <a:p>
-            <a:pPr algn="l" indent="0" marL="0">
+            <a:pPr marL="0" indent="0" algn="l">
               <a:lnSpc>
                 <a:spcPts val="3520"/>
               </a:lnSpc>
@@ -4420,6 +4270,13 @@
             <a:prstDash val="solid"/>
           </a:ln>
         </p:spPr>
+        <p:txBody>
+          <a:bodyPr/>
+          <a:lstStyle/>
+          <a:p>
+            <a:endParaRPr lang="es-CL"/>
+          </a:p>
+        </p:txBody>
       </p:sp>
       <p:sp>
         <p:nvSpPr>
@@ -4444,7 +4301,7 @@
           </a:bodyPr>
           <a:lstStyle/>
           <a:p>
-            <a:pPr algn="l" indent="0" marL="0">
+            <a:pPr marL="0" indent="0" algn="l">
               <a:lnSpc>
                 <a:spcPts val="2400"/>
               </a:lnSpc>
@@ -4488,7 +4345,7 @@
           </a:bodyPr>
           <a:lstStyle/>
           <a:p>
-            <a:pPr algn="l" indent="0" marL="0">
+            <a:pPr marL="0" indent="0" algn="l">
               <a:lnSpc>
                 <a:spcPts val="2100"/>
               </a:lnSpc>
@@ -4531,6 +4388,13 @@
             <a:prstDash val="solid"/>
           </a:ln>
         </p:spPr>
+        <p:txBody>
+          <a:bodyPr/>
+          <a:lstStyle/>
+          <a:p>
+            <a:endParaRPr lang="es-CL"/>
+          </a:p>
+        </p:txBody>
       </p:sp>
       <p:sp>
         <p:nvSpPr>
@@ -4555,7 +4419,7 @@
           </a:bodyPr>
           <a:lstStyle/>
           <a:p>
-            <a:pPr algn="l" indent="0" marL="0">
+            <a:pPr marL="0" indent="0" algn="l">
               <a:lnSpc>
                 <a:spcPts val="2400"/>
               </a:lnSpc>
@@ -4599,7 +4463,7 @@
           </a:bodyPr>
           <a:lstStyle/>
           <a:p>
-            <a:pPr algn="l" indent="0" marL="0">
+            <a:pPr marL="0" indent="0" algn="l">
               <a:lnSpc>
                 <a:spcPts val="2100"/>
               </a:lnSpc>
@@ -4642,6 +4506,13 @@
             <a:prstDash val="solid"/>
           </a:ln>
         </p:spPr>
+        <p:txBody>
+          <a:bodyPr/>
+          <a:lstStyle/>
+          <a:p>
+            <a:endParaRPr lang="es-CL"/>
+          </a:p>
+        </p:txBody>
       </p:sp>
       <p:sp>
         <p:nvSpPr>
@@ -4666,7 +4537,7 @@
           </a:bodyPr>
           <a:lstStyle/>
           <a:p>
-            <a:pPr algn="l" indent="0" marL="0">
+            <a:pPr marL="0" indent="0" algn="l">
               <a:lnSpc>
                 <a:spcPts val="2400"/>
               </a:lnSpc>
@@ -4710,7 +4581,7 @@
           </a:bodyPr>
           <a:lstStyle/>
           <a:p>
-            <a:pPr algn="l" indent="0" marL="0">
+            <a:pPr marL="0" indent="0" algn="l">
               <a:lnSpc>
                 <a:spcPts val="2100"/>
               </a:lnSpc>
@@ -4754,14 +4625,14 @@
           </a:bodyPr>
           <a:lstStyle/>
           <a:p>
-            <a:pPr algn="l" indent="0" marL="0">
+            <a:pPr marL="0" indent="0" algn="l">
               <a:lnSpc>
                 <a:spcPts val="1680"/>
               </a:lnSpc>
               <a:buNone/>
             </a:pPr>
             <a:r>
-              <a:rPr lang="en-US" sz="1200" b="1" spc="100" kern="0" dirty="0">
+              <a:rPr lang="en-US" sz="1200" b="1" kern="0" spc="100" dirty="0">
                 <a:solidFill>
                   <a:srgbClr val="F08A4B"/>
                 </a:solidFill>
@@ -4798,7 +4669,7 @@
           </a:bodyPr>
           <a:lstStyle/>
           <a:p>
-            <a:pPr algn="l" indent="0" marL="0">
+            <a:pPr marL="0" indent="0" algn="l">
               <a:lnSpc>
                 <a:spcPts val="1680"/>
               </a:lnSpc>
@@ -4835,6 +4706,7 @@
         <a:solidFill>
           <a:srgbClr val="F6F5F1"/>
         </a:solidFill>
+        <a:effectLst/>
       </p:bgPr>
     </p:bg>
     <p:spTree>
@@ -4874,14 +4746,14 @@
           </a:bodyPr>
           <a:lstStyle/>
           <a:p>
-            <a:pPr algn="l" indent="0" marL="0">
+            <a:pPr marL="0" indent="0" algn="l">
               <a:lnSpc>
                 <a:spcPts val="1680"/>
               </a:lnSpc>
               <a:buNone/>
             </a:pPr>
             <a:r>
-              <a:rPr lang="en-US" sz="1200" b="1" spc="100" kern="0" dirty="0">
+              <a:rPr lang="en-US" sz="1200" b="1" kern="0" spc="100" dirty="0">
                 <a:solidFill>
                   <a:srgbClr val="B34A18"/>
                 </a:solidFill>
@@ -4898,7 +4770,9 @@
       <p:sp>
         <p:nvSpPr>
           <p:cNvPr id="3" name="Text 1"/>
-          <p:cNvSpPr/>
+          <p:cNvSpPr>
+            <a:spLocks noGrp="1"/>
+          </p:cNvSpPr>
           <p:nvPr>
             <p:ph type="title"/>
           </p:nvPr>
@@ -4920,7 +4794,7 @@
           </a:bodyPr>
           <a:lstStyle/>
           <a:p>
-            <a:pPr algn="l" indent="0" marL="0">
+            <a:pPr marL="0" indent="0" algn="l">
               <a:lnSpc>
                 <a:spcPts val="3520"/>
               </a:lnSpc>
@@ -4967,6 +4841,13 @@
             <a:prstDash val="solid"/>
           </a:ln>
         </p:spPr>
+        <p:txBody>
+          <a:bodyPr/>
+          <a:lstStyle/>
+          <a:p>
+            <a:endParaRPr lang="es-CL"/>
+          </a:p>
+        </p:txBody>
       </p:sp>
       <p:sp>
         <p:nvSpPr>
@@ -4991,14 +4872,14 @@
           </a:bodyPr>
           <a:lstStyle/>
           <a:p>
-            <a:pPr algn="l" indent="0" marL="0">
+            <a:pPr marL="0" indent="0" algn="l">
               <a:lnSpc>
                 <a:spcPts val="1680"/>
               </a:lnSpc>
               <a:buNone/>
             </a:pPr>
             <a:r>
-              <a:rPr lang="en-US" sz="1200" b="1" spc="50" kern="0" dirty="0">
+              <a:rPr lang="en-US" sz="1200" b="1" kern="0" spc="50" dirty="0">
                 <a:solidFill>
                   <a:srgbClr val="5F6673"/>
                 </a:solidFill>
@@ -5035,7 +4916,7 @@
           </a:bodyPr>
           <a:lstStyle/>
           <a:p>
-            <a:pPr algn="l" indent="0" marL="0">
+            <a:pPr marL="0" indent="0" algn="l">
               <a:lnSpc>
                 <a:spcPts val="2400"/>
               </a:lnSpc>
@@ -5079,7 +4960,7 @@
           </a:bodyPr>
           <a:lstStyle/>
           <a:p>
-            <a:pPr algn="l" indent="0" marL="0">
+            <a:pPr marL="0" indent="0" algn="l">
               <a:lnSpc>
                 <a:spcPts val="4840"/>
               </a:lnSpc>
@@ -5123,7 +5004,7 @@
           </a:bodyPr>
           <a:lstStyle/>
           <a:p>
-            <a:pPr algn="l" indent="0" marL="0">
+            <a:pPr marL="0" indent="0" algn="l">
               <a:lnSpc>
                 <a:spcPts val="2100"/>
               </a:lnSpc>
@@ -5170,6 +5051,13 @@
             <a:prstDash val="solid"/>
           </a:ln>
         </p:spPr>
+        <p:txBody>
+          <a:bodyPr/>
+          <a:lstStyle/>
+          <a:p>
+            <a:endParaRPr lang="es-CL"/>
+          </a:p>
+        </p:txBody>
       </p:sp>
       <p:sp>
         <p:nvSpPr>
@@ -5194,14 +5082,14 @@
           </a:bodyPr>
           <a:lstStyle/>
           <a:p>
-            <a:pPr algn="l" indent="0" marL="0">
+            <a:pPr marL="0" indent="0" algn="l">
               <a:lnSpc>
                 <a:spcPts val="1680"/>
               </a:lnSpc>
               <a:buNone/>
             </a:pPr>
             <a:r>
-              <a:rPr lang="en-US" sz="1200" b="1" spc="50" kern="0" dirty="0">
+              <a:rPr lang="en-US" sz="1200" b="1" kern="0" spc="50" dirty="0">
                 <a:solidFill>
                   <a:srgbClr val="5F6673"/>
                 </a:solidFill>
@@ -5238,7 +5126,7 @@
           </a:bodyPr>
           <a:lstStyle/>
           <a:p>
-            <a:pPr algn="l" indent="0" marL="0">
+            <a:pPr marL="0" indent="0" algn="l">
               <a:lnSpc>
                 <a:spcPts val="2400"/>
               </a:lnSpc>
@@ -5282,7 +5170,7 @@
           </a:bodyPr>
           <a:lstStyle/>
           <a:p>
-            <a:pPr algn="l" indent="0" marL="0">
+            <a:pPr marL="0" indent="0" algn="l">
               <a:lnSpc>
                 <a:spcPts val="4840"/>
               </a:lnSpc>
@@ -5326,7 +5214,7 @@
           </a:bodyPr>
           <a:lstStyle/>
           <a:p>
-            <a:pPr algn="l" indent="0" marL="0">
+            <a:pPr marL="0" indent="0" algn="l">
               <a:lnSpc>
                 <a:spcPts val="2100"/>
               </a:lnSpc>
@@ -5373,6 +5261,13 @@
             <a:prstDash val="solid"/>
           </a:ln>
         </p:spPr>
+        <p:txBody>
+          <a:bodyPr/>
+          <a:lstStyle/>
+          <a:p>
+            <a:endParaRPr lang="es-CL"/>
+          </a:p>
+        </p:txBody>
       </p:sp>
       <p:sp>
         <p:nvSpPr>
@@ -5397,14 +5292,14 @@
           </a:bodyPr>
           <a:lstStyle/>
           <a:p>
-            <a:pPr algn="l" indent="0" marL="0">
+            <a:pPr marL="0" indent="0" algn="l">
               <a:lnSpc>
                 <a:spcPts val="1680"/>
               </a:lnSpc>
               <a:buNone/>
             </a:pPr>
             <a:r>
-              <a:rPr lang="en-US" sz="1200" b="1" spc="50" kern="0" dirty="0">
+              <a:rPr lang="en-US" sz="1200" b="1" kern="0" spc="50" dirty="0">
                 <a:solidFill>
                   <a:srgbClr val="5F6673"/>
                 </a:solidFill>
@@ -5441,7 +5336,7 @@
           </a:bodyPr>
           <a:lstStyle/>
           <a:p>
-            <a:pPr algn="l" indent="0" marL="0">
+            <a:pPr marL="0" indent="0" algn="l">
               <a:lnSpc>
                 <a:spcPts val="2400"/>
               </a:lnSpc>
@@ -5485,7 +5380,7 @@
           </a:bodyPr>
           <a:lstStyle/>
           <a:p>
-            <a:pPr algn="l" indent="0" marL="0">
+            <a:pPr marL="0" indent="0" algn="l">
               <a:lnSpc>
                 <a:spcPts val="4840"/>
               </a:lnSpc>
@@ -5529,7 +5424,7 @@
           </a:bodyPr>
           <a:lstStyle/>
           <a:p>
-            <a:pPr algn="l" indent="0" marL="0">
+            <a:pPr marL="0" indent="0" algn="l">
               <a:lnSpc>
                 <a:spcPts val="2100"/>
               </a:lnSpc>
@@ -5573,7 +5468,7 @@
           </a:bodyPr>
           <a:lstStyle/>
           <a:p>
-            <a:pPr algn="l" indent="0" marL="0">
+            <a:pPr marL="0" indent="0" algn="l">
               <a:lnSpc>
                 <a:spcPts val="1680"/>
               </a:lnSpc>
@@ -5617,7 +5512,7 @@
           </a:bodyPr>
           <a:lstStyle/>
           <a:p>
-            <a:pPr algn="r" indent="0" marL="0">
+            <a:pPr marL="0" indent="0" algn="r">
               <a:lnSpc>
                 <a:spcPts val="1680"/>
               </a:lnSpc>
@@ -5654,6 +5549,7 @@
         <a:solidFill>
           <a:srgbClr val="F6F5F1"/>
         </a:solidFill>
+        <a:effectLst/>
       </p:bgPr>
     </p:bg>
     <p:spTree>
@@ -5693,14 +5589,14 @@
           </a:bodyPr>
           <a:lstStyle/>
           <a:p>
-            <a:pPr algn="l" indent="0" marL="0">
+            <a:pPr marL="0" indent="0" algn="l">
               <a:lnSpc>
                 <a:spcPts val="1680"/>
               </a:lnSpc>
               <a:buNone/>
             </a:pPr>
             <a:r>
-              <a:rPr lang="en-US" sz="1200" b="1" spc="100" kern="0" dirty="0">
+              <a:rPr lang="en-US" sz="1200" b="1" kern="0" spc="100" dirty="0">
                 <a:solidFill>
                   <a:srgbClr val="B34A18"/>
                 </a:solidFill>
@@ -5717,7 +5613,9 @@
       <p:sp>
         <p:nvSpPr>
           <p:cNvPr id="3" name="Text 1"/>
-          <p:cNvSpPr/>
+          <p:cNvSpPr>
+            <a:spLocks noGrp="1"/>
+          </p:cNvSpPr>
           <p:nvPr>
             <p:ph type="title"/>
           </p:nvPr>
@@ -5739,7 +5637,7 @@
           </a:bodyPr>
           <a:lstStyle/>
           <a:p>
-            <a:pPr algn="l" indent="0" marL="0">
+            <a:pPr marL="0" indent="0" algn="l">
               <a:lnSpc>
                 <a:spcPts val="3520"/>
               </a:lnSpc>
@@ -5783,7 +5681,7 @@
           </a:bodyPr>
           <a:lstStyle/>
           <a:p>
-            <a:pPr algn="l" indent="0" marL="0">
+            <a:pPr marL="0" indent="0" algn="l">
               <a:lnSpc>
                 <a:spcPts val="1680"/>
               </a:lnSpc>
@@ -5827,7 +5725,7 @@
           </a:bodyPr>
           <a:lstStyle/>
           <a:p>
-            <a:pPr algn="l" indent="0" marL="0">
+            <a:pPr marL="0" indent="0" algn="l">
               <a:lnSpc>
                 <a:spcPts val="2100"/>
               </a:lnSpc>
@@ -5867,6 +5765,13 @@
           </a:solidFill>
           <a:ln/>
         </p:spPr>
+        <p:txBody>
+          <a:bodyPr/>
+          <a:lstStyle/>
+          <a:p>
+            <a:endParaRPr lang="es-CL"/>
+          </a:p>
+        </p:txBody>
       </p:sp>
       <p:sp>
         <p:nvSpPr>
@@ -5891,7 +5796,7 @@
           </a:bodyPr>
           <a:lstStyle/>
           <a:p>
-            <a:pPr algn="l" indent="0" marL="0">
+            <a:pPr marL="0" indent="0" algn="l">
               <a:lnSpc>
                 <a:spcPts val="2100"/>
               </a:lnSpc>
@@ -5935,7 +5840,7 @@
           </a:bodyPr>
           <a:lstStyle/>
           <a:p>
-            <a:pPr algn="l" indent="0" marL="0">
+            <a:pPr marL="0" indent="0" algn="l">
               <a:lnSpc>
                 <a:spcPts val="1680"/>
               </a:lnSpc>
@@ -5979,7 +5884,7 @@
           </a:bodyPr>
           <a:lstStyle/>
           <a:p>
-            <a:pPr algn="l" indent="0" marL="0">
+            <a:pPr marL="0" indent="0" algn="l">
               <a:lnSpc>
                 <a:spcPts val="2100"/>
               </a:lnSpc>
@@ -6019,6 +5924,13 @@
           </a:solidFill>
           <a:ln/>
         </p:spPr>
+        <p:txBody>
+          <a:bodyPr/>
+          <a:lstStyle/>
+          <a:p>
+            <a:endParaRPr lang="es-CL"/>
+          </a:p>
+        </p:txBody>
       </p:sp>
       <p:sp>
         <p:nvSpPr>
@@ -6043,7 +5955,7 @@
           </a:bodyPr>
           <a:lstStyle/>
           <a:p>
-            <a:pPr algn="l" indent="0" marL="0">
+            <a:pPr marL="0" indent="0" algn="l">
               <a:lnSpc>
                 <a:spcPts val="2100"/>
               </a:lnSpc>
@@ -6087,7 +5999,7 @@
           </a:bodyPr>
           <a:lstStyle/>
           <a:p>
-            <a:pPr algn="l" indent="0" marL="0">
+            <a:pPr marL="0" indent="0" algn="l">
               <a:lnSpc>
                 <a:spcPts val="1680"/>
               </a:lnSpc>
@@ -6131,7 +6043,7 @@
           </a:bodyPr>
           <a:lstStyle/>
           <a:p>
-            <a:pPr algn="l" indent="0" marL="0">
+            <a:pPr marL="0" indent="0" algn="l">
               <a:lnSpc>
                 <a:spcPts val="2100"/>
               </a:lnSpc>
@@ -6175,7 +6087,7 @@
           </a:bodyPr>
           <a:lstStyle/>
           <a:p>
-            <a:pPr algn="l" indent="0" marL="0">
+            <a:pPr marL="0" indent="0" algn="l">
               <a:lnSpc>
                 <a:spcPts val="2100"/>
               </a:lnSpc>
@@ -6219,7 +6131,7 @@
           </a:bodyPr>
           <a:lstStyle/>
           <a:p>
-            <a:pPr algn="l" indent="0" marL="0">
+            <a:pPr marL="0" indent="0" algn="l">
               <a:lnSpc>
                 <a:spcPts val="1680"/>
               </a:lnSpc>
@@ -6263,7 +6175,7 @@
           </a:bodyPr>
           <a:lstStyle/>
           <a:p>
-            <a:pPr algn="l" indent="0" marL="0">
+            <a:pPr marL="0" indent="0" algn="l">
               <a:lnSpc>
                 <a:spcPts val="1680"/>
               </a:lnSpc>
@@ -6307,7 +6219,7 @@
           </a:bodyPr>
           <a:lstStyle/>
           <a:p>
-            <a:pPr algn="l" indent="0" marL="0">
+            <a:pPr marL="0" indent="0" algn="l">
               <a:lnSpc>
                 <a:spcPts val="2400"/>
               </a:lnSpc>
@@ -6351,7 +6263,7 @@
           </a:bodyPr>
           <a:lstStyle/>
           <a:p>
-            <a:pPr algn="l" indent="0" marL="0">
+            <a:pPr marL="0" indent="0" algn="l">
               <a:lnSpc>
                 <a:spcPts val="2100"/>
               </a:lnSpc>
@@ -6395,7 +6307,7 @@
           </a:bodyPr>
           <a:lstStyle/>
           <a:p>
-            <a:pPr algn="l" indent="0" marL="0">
+            <a:pPr marL="0" indent="0" algn="l">
               <a:lnSpc>
                 <a:spcPts val="2400"/>
               </a:lnSpc>
@@ -6439,7 +6351,7 @@
           </a:bodyPr>
           <a:lstStyle/>
           <a:p>
-            <a:pPr algn="l" indent="0" marL="0">
+            <a:pPr marL="0" indent="0" algn="l">
               <a:lnSpc>
                 <a:spcPts val="2100"/>
               </a:lnSpc>
@@ -6483,7 +6395,7 @@
           </a:bodyPr>
           <a:lstStyle/>
           <a:p>
-            <a:pPr algn="l" indent="0" marL="0">
+            <a:pPr marL="0" indent="0" algn="l">
               <a:lnSpc>
                 <a:spcPts val="1680"/>
               </a:lnSpc>
@@ -6527,7 +6439,7 @@
           </a:bodyPr>
           <a:lstStyle/>
           <a:p>
-            <a:pPr algn="r" indent="0" marL="0">
+            <a:pPr marL="0" indent="0" algn="r">
               <a:lnSpc>
                 <a:spcPts val="1680"/>
               </a:lnSpc>
@@ -6564,6 +6476,7 @@
         <a:solidFill>
           <a:srgbClr val="F6F5F1"/>
         </a:solidFill>
+        <a:effectLst/>
       </p:bgPr>
     </p:bg>
     <p:spTree>
@@ -6603,14 +6516,14 @@
           </a:bodyPr>
           <a:lstStyle/>
           <a:p>
-            <a:pPr algn="l" indent="0" marL="0">
+            <a:pPr marL="0" indent="0" algn="l">
               <a:lnSpc>
                 <a:spcPts val="1680"/>
               </a:lnSpc>
               <a:buNone/>
             </a:pPr>
             <a:r>
-              <a:rPr lang="en-US" sz="1200" b="1" spc="100" kern="0" dirty="0">
+              <a:rPr lang="en-US" sz="1200" b="1" kern="0" spc="100" dirty="0">
                 <a:solidFill>
                   <a:srgbClr val="B34A18"/>
                 </a:solidFill>
@@ -6627,7 +6540,9 @@
       <p:sp>
         <p:nvSpPr>
           <p:cNvPr id="3" name="Text 1"/>
-          <p:cNvSpPr/>
+          <p:cNvSpPr>
+            <a:spLocks noGrp="1"/>
+          </p:cNvSpPr>
           <p:nvPr>
             <p:ph type="title"/>
           </p:nvPr>
@@ -6649,7 +6564,7 @@
           </a:bodyPr>
           <a:lstStyle/>
           <a:p>
-            <a:pPr algn="l" indent="0" marL="0">
+            <a:pPr marL="0" indent="0" algn="l">
               <a:lnSpc>
                 <a:spcPts val="3520"/>
               </a:lnSpc>
@@ -6693,7 +6608,7 @@
           </a:bodyPr>
           <a:lstStyle/>
           <a:p>
-            <a:pPr algn="l" indent="0" marL="0">
+            <a:pPr marL="0" indent="0" algn="l">
               <a:lnSpc>
                 <a:spcPts val="1680"/>
               </a:lnSpc>
@@ -6736,6 +6651,13 @@
             <a:prstDash val="solid"/>
           </a:ln>
         </p:spPr>
+        <p:txBody>
+          <a:bodyPr/>
+          <a:lstStyle/>
+          <a:p>
+            <a:endParaRPr lang="es-CL"/>
+          </a:p>
+        </p:txBody>
       </p:sp>
       <p:sp>
         <p:nvSpPr>
@@ -6760,7 +6682,7 @@
           </a:bodyPr>
           <a:lstStyle/>
           <a:p>
-            <a:pPr algn="ctr" indent="0" marL="0">
+            <a:pPr marL="0" indent="0" algn="ctr">
               <a:lnSpc>
                 <a:spcPts val="2100"/>
               </a:lnSpc>
@@ -6800,6 +6722,13 @@
           </a:solidFill>
           <a:ln/>
         </p:spPr>
+        <p:txBody>
+          <a:bodyPr/>
+          <a:lstStyle/>
+          <a:p>
+            <a:endParaRPr lang="es-CL"/>
+          </a:p>
+        </p:txBody>
       </p:sp>
       <p:sp>
         <p:nvSpPr>
@@ -6824,7 +6753,7 @@
           </a:bodyPr>
           <a:lstStyle/>
           <a:p>
-            <a:pPr algn="ctr" indent="0" marL="0">
+            <a:pPr marL="0" indent="0" algn="ctr">
               <a:lnSpc>
                 <a:spcPts val="2800"/>
               </a:lnSpc>
@@ -6868,7 +6797,7 @@
           </a:bodyPr>
           <a:lstStyle/>
           <a:p>
-            <a:pPr algn="ctr" indent="0" marL="0">
+            <a:pPr marL="0" indent="0" algn="ctr">
               <a:lnSpc>
                 <a:spcPts val="1680"/>
               </a:lnSpc>
@@ -6912,7 +6841,7 @@
           </a:bodyPr>
           <a:lstStyle/>
           <a:p>
-            <a:pPr algn="ctr" indent="0" marL="0">
+            <a:pPr marL="0" indent="0" algn="ctr">
               <a:lnSpc>
                 <a:spcPts val="2100"/>
               </a:lnSpc>
@@ -6952,6 +6881,13 @@
           </a:solidFill>
           <a:ln/>
         </p:spPr>
+        <p:txBody>
+          <a:bodyPr/>
+          <a:lstStyle/>
+          <a:p>
+            <a:endParaRPr lang="es-CL"/>
+          </a:p>
+        </p:txBody>
       </p:sp>
       <p:sp>
         <p:nvSpPr>
@@ -6976,7 +6912,7 @@
           </a:bodyPr>
           <a:lstStyle/>
           <a:p>
-            <a:pPr algn="ctr" indent="0" marL="0">
+            <a:pPr marL="0" indent="0" algn="ctr">
               <a:lnSpc>
                 <a:spcPts val="2800"/>
               </a:lnSpc>
@@ -7020,7 +6956,7 @@
           </a:bodyPr>
           <a:lstStyle/>
           <a:p>
-            <a:pPr algn="ctr" indent="0" marL="0">
+            <a:pPr marL="0" indent="0" algn="ctr">
               <a:lnSpc>
                 <a:spcPts val="1680"/>
               </a:lnSpc>
@@ -7064,7 +7000,7 @@
           </a:bodyPr>
           <a:lstStyle/>
           <a:p>
-            <a:pPr algn="ctr" indent="0" marL="0">
+            <a:pPr marL="0" indent="0" algn="ctr">
               <a:lnSpc>
                 <a:spcPts val="2100"/>
               </a:lnSpc>
@@ -7104,6 +7040,13 @@
           </a:solidFill>
           <a:ln/>
         </p:spPr>
+        <p:txBody>
+          <a:bodyPr/>
+          <a:lstStyle/>
+          <a:p>
+            <a:endParaRPr lang="es-CL"/>
+          </a:p>
+        </p:txBody>
       </p:sp>
       <p:sp>
         <p:nvSpPr>
@@ -7128,7 +7071,7 @@
           </a:bodyPr>
           <a:lstStyle/>
           <a:p>
-            <a:pPr algn="ctr" indent="0" marL="0">
+            <a:pPr marL="0" indent="0" algn="ctr">
               <a:lnSpc>
                 <a:spcPts val="2800"/>
               </a:lnSpc>
@@ -7172,7 +7115,7 @@
           </a:bodyPr>
           <a:lstStyle/>
           <a:p>
-            <a:pPr algn="ctr" indent="0" marL="0">
+            <a:pPr marL="0" indent="0" algn="ctr">
               <a:lnSpc>
                 <a:spcPts val="1680"/>
               </a:lnSpc>
@@ -7216,7 +7159,7 @@
           </a:bodyPr>
           <a:lstStyle/>
           <a:p>
-            <a:pPr algn="ctr" indent="0" marL="0">
+            <a:pPr marL="0" indent="0" algn="ctr">
               <a:lnSpc>
                 <a:spcPts val="2100"/>
               </a:lnSpc>
@@ -7256,6 +7199,13 @@
           </a:solidFill>
           <a:ln/>
         </p:spPr>
+        <p:txBody>
+          <a:bodyPr/>
+          <a:lstStyle/>
+          <a:p>
+            <a:endParaRPr lang="es-CL"/>
+          </a:p>
+        </p:txBody>
       </p:sp>
       <p:sp>
         <p:nvSpPr>
@@ -7280,7 +7230,7 @@
           </a:bodyPr>
           <a:lstStyle/>
           <a:p>
-            <a:pPr algn="ctr" indent="0" marL="0">
+            <a:pPr marL="0" indent="0" algn="ctr">
               <a:lnSpc>
                 <a:spcPts val="2800"/>
               </a:lnSpc>
@@ -7324,7 +7274,7 @@
           </a:bodyPr>
           <a:lstStyle/>
           <a:p>
-            <a:pPr algn="ctr" indent="0" marL="0">
+            <a:pPr marL="0" indent="0" algn="ctr">
               <a:lnSpc>
                 <a:spcPts val="1680"/>
               </a:lnSpc>
@@ -7368,7 +7318,7 @@
           </a:bodyPr>
           <a:lstStyle/>
           <a:p>
-            <a:pPr algn="l" indent="0" marL="0">
+            <a:pPr marL="0" indent="0" algn="l">
               <a:lnSpc>
                 <a:spcPts val="4840"/>
               </a:lnSpc>
@@ -7412,7 +7362,7 @@
           </a:bodyPr>
           <a:lstStyle/>
           <a:p>
-            <a:pPr algn="l" indent="0" marL="0">
+            <a:pPr marL="0" indent="0" algn="l">
               <a:lnSpc>
                 <a:spcPts val="2100"/>
               </a:lnSpc>
@@ -7455,6 +7405,13 @@
             <a:prstDash val="solid"/>
           </a:ln>
         </p:spPr>
+        <p:txBody>
+          <a:bodyPr/>
+          <a:lstStyle/>
+          <a:p>
+            <a:endParaRPr lang="es-CL"/>
+          </a:p>
+        </p:txBody>
       </p:sp>
       <p:sp>
         <p:nvSpPr>
@@ -7479,7 +7436,7 @@
           </a:bodyPr>
           <a:lstStyle/>
           <a:p>
-            <a:pPr algn="l" indent="0" marL="0">
+            <a:pPr marL="0" indent="0" algn="l">
               <a:lnSpc>
                 <a:spcPts val="2100"/>
               </a:lnSpc>
@@ -7534,7 +7491,7 @@
           </a:bodyPr>
           <a:lstStyle/>
           <a:p>
-            <a:pPr algn="l" indent="0" marL="0">
+            <a:pPr marL="0" indent="0" algn="l">
               <a:lnSpc>
                 <a:spcPts val="1680"/>
               </a:lnSpc>
@@ -7578,7 +7535,7 @@
           </a:bodyPr>
           <a:lstStyle/>
           <a:p>
-            <a:pPr algn="r" indent="0" marL="0">
+            <a:pPr marL="0" indent="0" algn="r">
               <a:lnSpc>
                 <a:spcPts val="1680"/>
               </a:lnSpc>
@@ -7615,6 +7572,7 @@
         <a:solidFill>
           <a:srgbClr val="F6F5F1"/>
         </a:solidFill>
+        <a:effectLst/>
       </p:bgPr>
     </p:bg>
     <p:spTree>
@@ -7654,14 +7612,14 @@
           </a:bodyPr>
           <a:lstStyle/>
           <a:p>
-            <a:pPr algn="l" indent="0" marL="0">
+            <a:pPr marL="0" indent="0" algn="l">
               <a:lnSpc>
                 <a:spcPts val="1680"/>
               </a:lnSpc>
               <a:buNone/>
             </a:pPr>
             <a:r>
-              <a:rPr lang="en-US" sz="1200" b="1" spc="100" kern="0" dirty="0">
+              <a:rPr lang="en-US" sz="1200" b="1" kern="0" spc="100" dirty="0">
                 <a:solidFill>
                   <a:srgbClr val="B34A18"/>
                 </a:solidFill>
@@ -7678,7 +7636,9 @@
       <p:sp>
         <p:nvSpPr>
           <p:cNvPr id="3" name="Text 1"/>
-          <p:cNvSpPr/>
+          <p:cNvSpPr>
+            <a:spLocks noGrp="1"/>
+          </p:cNvSpPr>
           <p:nvPr>
             <p:ph type="title"/>
           </p:nvPr>
@@ -7700,7 +7660,7 @@
           </a:bodyPr>
           <a:lstStyle/>
           <a:p>
-            <a:pPr algn="l" indent="0" marL="0">
+            <a:pPr marL="0" indent="0" algn="l">
               <a:lnSpc>
                 <a:spcPts val="3520"/>
               </a:lnSpc>
@@ -7744,7 +7704,7 @@
           </a:bodyPr>
           <a:lstStyle/>
           <a:p>
-            <a:pPr algn="l" indent="0" marL="0">
+            <a:pPr marL="0" indent="0" algn="l">
               <a:lnSpc>
                 <a:spcPts val="1680"/>
               </a:lnSpc>
@@ -7787,6 +7747,13 @@
             <a:prstDash val="solid"/>
           </a:ln>
         </p:spPr>
+        <p:txBody>
+          <a:bodyPr/>
+          <a:lstStyle/>
+          <a:p>
+            <a:endParaRPr lang="es-CL"/>
+          </a:p>
+        </p:txBody>
       </p:sp>
       <p:sp>
         <p:nvSpPr>
@@ -7811,7 +7778,7 @@
           </a:bodyPr>
           <a:lstStyle/>
           <a:p>
-            <a:pPr algn="ctr" indent="0" marL="0">
+            <a:pPr marL="0" indent="0" algn="ctr">
               <a:lnSpc>
                 <a:spcPts val="2100"/>
               </a:lnSpc>
@@ -7851,6 +7818,13 @@
           </a:solidFill>
           <a:ln/>
         </p:spPr>
+        <p:txBody>
+          <a:bodyPr/>
+          <a:lstStyle/>
+          <a:p>
+            <a:endParaRPr lang="es-CL"/>
+          </a:p>
+        </p:txBody>
       </p:sp>
       <p:sp>
         <p:nvSpPr>
@@ -7875,7 +7849,7 @@
           </a:bodyPr>
           <a:lstStyle/>
           <a:p>
-            <a:pPr algn="ctr" indent="0" marL="0">
+            <a:pPr marL="0" indent="0" algn="ctr">
               <a:lnSpc>
                 <a:spcPts val="2100"/>
               </a:lnSpc>
@@ -7919,7 +7893,7 @@
           </a:bodyPr>
           <a:lstStyle/>
           <a:p>
-            <a:pPr algn="ctr" indent="0" marL="0">
+            <a:pPr marL="0" indent="0" algn="ctr">
               <a:lnSpc>
                 <a:spcPts val="1680"/>
               </a:lnSpc>
@@ -7963,7 +7937,7 @@
           </a:bodyPr>
           <a:lstStyle/>
           <a:p>
-            <a:pPr algn="ctr" indent="0" marL="0">
+            <a:pPr marL="0" indent="0" algn="ctr">
               <a:lnSpc>
                 <a:spcPts val="2100"/>
               </a:lnSpc>
@@ -8003,6 +7977,13 @@
           </a:solidFill>
           <a:ln/>
         </p:spPr>
+        <p:txBody>
+          <a:bodyPr/>
+          <a:lstStyle/>
+          <a:p>
+            <a:endParaRPr lang="es-CL"/>
+          </a:p>
+        </p:txBody>
       </p:sp>
       <p:sp>
         <p:nvSpPr>
@@ -8027,7 +8008,7 @@
           </a:bodyPr>
           <a:lstStyle/>
           <a:p>
-            <a:pPr algn="ctr" indent="0" marL="0">
+            <a:pPr marL="0" indent="0" algn="ctr">
               <a:lnSpc>
                 <a:spcPts val="2100"/>
               </a:lnSpc>
@@ -8071,7 +8052,7 @@
           </a:bodyPr>
           <a:lstStyle/>
           <a:p>
-            <a:pPr algn="ctr" indent="0" marL="0">
+            <a:pPr marL="0" indent="0" algn="ctr">
               <a:lnSpc>
                 <a:spcPts val="1680"/>
               </a:lnSpc>
@@ -8115,7 +8096,7 @@
           </a:bodyPr>
           <a:lstStyle/>
           <a:p>
-            <a:pPr algn="ctr" indent="0" marL="0">
+            <a:pPr marL="0" indent="0" algn="ctr">
               <a:lnSpc>
                 <a:spcPts val="2100"/>
               </a:lnSpc>
@@ -8155,6 +8136,13 @@
           </a:solidFill>
           <a:ln/>
         </p:spPr>
+        <p:txBody>
+          <a:bodyPr/>
+          <a:lstStyle/>
+          <a:p>
+            <a:endParaRPr lang="es-CL"/>
+          </a:p>
+        </p:txBody>
       </p:sp>
       <p:sp>
         <p:nvSpPr>
@@ -8179,7 +8167,7 @@
           </a:bodyPr>
           <a:lstStyle/>
           <a:p>
-            <a:pPr algn="ctr" indent="0" marL="0">
+            <a:pPr marL="0" indent="0" algn="ctr">
               <a:lnSpc>
                 <a:spcPts val="2100"/>
               </a:lnSpc>
@@ -8223,7 +8211,7 @@
           </a:bodyPr>
           <a:lstStyle/>
           <a:p>
-            <a:pPr algn="ctr" indent="0" marL="0">
+            <a:pPr marL="0" indent="0" algn="ctr">
               <a:lnSpc>
                 <a:spcPts val="1680"/>
               </a:lnSpc>
@@ -8267,7 +8255,7 @@
           </a:bodyPr>
           <a:lstStyle/>
           <a:p>
-            <a:pPr algn="ctr" indent="0" marL="0">
+            <a:pPr marL="0" indent="0" algn="ctr">
               <a:lnSpc>
                 <a:spcPts val="2100"/>
               </a:lnSpc>
@@ -8307,6 +8295,13 @@
           </a:solidFill>
           <a:ln/>
         </p:spPr>
+        <p:txBody>
+          <a:bodyPr/>
+          <a:lstStyle/>
+          <a:p>
+            <a:endParaRPr lang="es-CL"/>
+          </a:p>
+        </p:txBody>
       </p:sp>
       <p:sp>
         <p:nvSpPr>
@@ -8331,7 +8326,7 @@
           </a:bodyPr>
           <a:lstStyle/>
           <a:p>
-            <a:pPr algn="ctr" indent="0" marL="0">
+            <a:pPr marL="0" indent="0" algn="ctr">
               <a:lnSpc>
                 <a:spcPts val="2100"/>
               </a:lnSpc>
@@ -8375,7 +8370,7 @@
           </a:bodyPr>
           <a:lstStyle/>
           <a:p>
-            <a:pPr algn="ctr" indent="0" marL="0">
+            <a:pPr marL="0" indent="0" algn="ctr">
               <a:lnSpc>
                 <a:spcPts val="1680"/>
               </a:lnSpc>
@@ -8419,7 +8414,7 @@
           </a:bodyPr>
           <a:lstStyle/>
           <a:p>
-            <a:pPr algn="ctr" indent="0" marL="0">
+            <a:pPr marL="0" indent="0" algn="ctr">
               <a:lnSpc>
                 <a:spcPts val="2100"/>
               </a:lnSpc>
@@ -8459,6 +8454,13 @@
           </a:solidFill>
           <a:ln/>
         </p:spPr>
+        <p:txBody>
+          <a:bodyPr/>
+          <a:lstStyle/>
+          <a:p>
+            <a:endParaRPr lang="es-CL"/>
+          </a:p>
+        </p:txBody>
       </p:sp>
       <p:sp>
         <p:nvSpPr>
@@ -8483,7 +8485,7 @@
           </a:bodyPr>
           <a:lstStyle/>
           <a:p>
-            <a:pPr algn="ctr" indent="0" marL="0">
+            <a:pPr marL="0" indent="0" algn="ctr">
               <a:lnSpc>
                 <a:spcPts val="2100"/>
               </a:lnSpc>
@@ -8527,7 +8529,7 @@
           </a:bodyPr>
           <a:lstStyle/>
           <a:p>
-            <a:pPr algn="ctr" indent="0" marL="0">
+            <a:pPr marL="0" indent="0" algn="ctr">
               <a:lnSpc>
                 <a:spcPts val="1680"/>
               </a:lnSpc>
@@ -8571,7 +8573,7 @@
           </a:bodyPr>
           <a:lstStyle/>
           <a:p>
-            <a:pPr algn="ctr" indent="0" marL="0">
+            <a:pPr marL="0" indent="0" algn="ctr">
               <a:lnSpc>
                 <a:spcPts val="2100"/>
               </a:lnSpc>
@@ -8611,6 +8613,13 @@
           </a:solidFill>
           <a:ln/>
         </p:spPr>
+        <p:txBody>
+          <a:bodyPr/>
+          <a:lstStyle/>
+          <a:p>
+            <a:endParaRPr lang="es-CL"/>
+          </a:p>
+        </p:txBody>
       </p:sp>
       <p:sp>
         <p:nvSpPr>
@@ -8635,7 +8644,7 @@
           </a:bodyPr>
           <a:lstStyle/>
           <a:p>
-            <a:pPr algn="ctr" indent="0" marL="0">
+            <a:pPr marL="0" indent="0" algn="ctr">
               <a:lnSpc>
                 <a:spcPts val="2100"/>
               </a:lnSpc>
@@ -8679,7 +8688,7 @@
           </a:bodyPr>
           <a:lstStyle/>
           <a:p>
-            <a:pPr algn="ctr" indent="0" marL="0">
+            <a:pPr marL="0" indent="0" algn="ctr">
               <a:lnSpc>
                 <a:spcPts val="1680"/>
               </a:lnSpc>
@@ -8723,7 +8732,7 @@
           </a:bodyPr>
           <a:lstStyle/>
           <a:p>
-            <a:pPr algn="l" indent="0" marL="0">
+            <a:pPr marL="0" indent="0" algn="l">
               <a:lnSpc>
                 <a:spcPts val="2400"/>
               </a:lnSpc>
@@ -8767,8 +8776,20 @@
             <a:tbl>
               <a:tblPr/>
               <a:tblGrid>
-                <a:gridCol w="2659380"/>
-                <a:gridCol w="1772920"/>
+                <a:gridCol w="2659380">
+                  <a:extLst>
+                    <a:ext uri="{9D8B030D-6E8A-4147-A177-3AD203B41FA5}">
+                      <a16:colId xmlns:a16="http://schemas.microsoft.com/office/drawing/2014/main" val="20000"/>
+                    </a:ext>
+                  </a:extLst>
+                </a:gridCol>
+                <a:gridCol w="1772920">
+                  <a:extLst>
+                    <a:ext uri="{9D8B030D-6E8A-4147-A177-3AD203B41FA5}">
+                      <a16:colId xmlns:a16="http://schemas.microsoft.com/office/drawing/2014/main" val="20001"/>
+                    </a:ext>
+                  </a:extLst>
+                </a:gridCol>
               </a:tblGrid>
               <a:tr h="412750">
                 <a:tc>
@@ -8776,7 +8797,7 @@
                     <a:bodyPr/>
                     <a:lstStyle/>
                     <a:p>
-                      <a:pPr indent="0" marL="0">
+                      <a:pPr marL="0" indent="0">
                         <a:lnSpc>
                           <a:spcPts val="2100"/>
                         </a:lnSpc>
@@ -8800,7 +8821,7 @@
                       </a:endParaRPr>
                     </a:p>
                   </a:txBody>
-                  <a:tcPr marL="66675" marR="66675" marT="66675" marB="66675" anchor="t">
+                  <a:tcPr marL="66675" marR="66675" marT="66675" marB="66675">
                     <a:lnL w="12700" cap="flat" cmpd="sng" algn="ctr">
                       <a:solidFill>
                         <a:srgbClr val="C4C4C0"/>
@@ -8847,7 +8868,7 @@
                     <a:bodyPr/>
                     <a:lstStyle/>
                     <a:p>
-                      <a:pPr algn="r" indent="0" marL="0">
+                      <a:pPr marL="0" indent="0" algn="r">
                         <a:lnSpc>
                           <a:spcPts val="2100"/>
                         </a:lnSpc>
@@ -8871,7 +8892,7 @@
                       </a:endParaRPr>
                     </a:p>
                   </a:txBody>
-                  <a:tcPr marL="66675" marR="66675" marT="66675" marB="66675" anchor="t">
+                  <a:tcPr marL="66675" marR="66675" marT="66675" marB="66675">
                     <a:lnL w="12700" cap="flat" cmpd="sng" algn="ctr">
                       <a:solidFill>
                         <a:srgbClr val="B6B5B2"/>
@@ -8913,6 +8934,11 @@
                     </a:solidFill>
                   </a:tcPr>
                 </a:tc>
+                <a:extLst>
+                  <a:ext uri="{0D108BD9-81ED-4DB2-BD59-A6C34878D82A}">
+                    <a16:rowId xmlns:a16="http://schemas.microsoft.com/office/drawing/2014/main" val="10000"/>
+                  </a:ext>
+                </a:extLst>
               </a:tr>
               <a:tr h="412750">
                 <a:tc>
@@ -8920,7 +8946,7 @@
                     <a:bodyPr/>
                     <a:lstStyle/>
                     <a:p>
-                      <a:pPr indent="0" marL="0">
+                      <a:pPr marL="0" indent="0">
                         <a:lnSpc>
                           <a:spcPts val="2100"/>
                         </a:lnSpc>
@@ -8944,7 +8970,7 @@
                       </a:endParaRPr>
                     </a:p>
                   </a:txBody>
-                  <a:tcPr marL="66675" marR="66675" marT="66675" marB="66675" anchor="t">
+                  <a:tcPr marL="66675" marR="66675" marT="66675" marB="66675">
                     <a:lnL w="12700" cap="flat" cmpd="sng" algn="ctr">
                       <a:solidFill>
                         <a:srgbClr val="C4C4C0"/>
@@ -8988,7 +9014,7 @@
                     <a:bodyPr/>
                     <a:lstStyle/>
                     <a:p>
-                      <a:pPr algn="r" indent="0" marL="0">
+                      <a:pPr marL="0" indent="0" algn="r">
                         <a:lnSpc>
                           <a:spcPts val="2100"/>
                         </a:lnSpc>
@@ -9012,7 +9038,7 @@
                       </a:endParaRPr>
                     </a:p>
                   </a:txBody>
-                  <a:tcPr marL="66675" marR="66675" marT="66675" marB="66675" anchor="t">
+                  <a:tcPr marL="66675" marR="66675" marT="66675" marB="66675">
                     <a:lnL w="12700" cap="flat" cmpd="sng" algn="ctr">
                       <a:solidFill>
                         <a:srgbClr val="C4C4C0"/>
@@ -9051,6 +9077,11 @@
                     </a:lnB>
                   </a:tcPr>
                 </a:tc>
+                <a:extLst>
+                  <a:ext uri="{0D108BD9-81ED-4DB2-BD59-A6C34878D82A}">
+                    <a16:rowId xmlns:a16="http://schemas.microsoft.com/office/drawing/2014/main" val="10001"/>
+                  </a:ext>
+                </a:extLst>
               </a:tr>
               <a:tr h="412750">
                 <a:tc>
@@ -9058,7 +9089,7 @@
                     <a:bodyPr/>
                     <a:lstStyle/>
                     <a:p>
-                      <a:pPr indent="0" marL="0">
+                      <a:pPr marL="0" indent="0">
                         <a:lnSpc>
                           <a:spcPts val="2100"/>
                         </a:lnSpc>
@@ -9082,7 +9113,7 @@
                       </a:endParaRPr>
                     </a:p>
                   </a:txBody>
-                  <a:tcPr marL="66675" marR="66675" marT="66675" marB="66675" anchor="t">
+                  <a:tcPr marL="66675" marR="66675" marT="66675" marB="66675">
                     <a:lnL w="12700" cap="flat" cmpd="sng" algn="ctr">
                       <a:solidFill>
                         <a:srgbClr val="C4C4C0"/>
@@ -9126,7 +9157,7 @@
                     <a:bodyPr/>
                     <a:lstStyle/>
                     <a:p>
-                      <a:pPr algn="r" indent="0" marL="0">
+                      <a:pPr marL="0" indent="0" algn="r">
                         <a:lnSpc>
                           <a:spcPts val="2100"/>
                         </a:lnSpc>
@@ -9150,7 +9181,7 @@
                       </a:endParaRPr>
                     </a:p>
                   </a:txBody>
-                  <a:tcPr marL="66675" marR="66675" marT="66675" marB="66675" anchor="t">
+                  <a:tcPr marL="66675" marR="66675" marT="66675" marB="66675">
                     <a:lnL w="12700" cap="flat" cmpd="sng" algn="ctr">
                       <a:solidFill>
                         <a:srgbClr val="C4C4C0"/>
@@ -9189,6 +9220,11 @@
                     </a:lnB>
                   </a:tcPr>
                 </a:tc>
+                <a:extLst>
+                  <a:ext uri="{0D108BD9-81ED-4DB2-BD59-A6C34878D82A}">
+                    <a16:rowId xmlns:a16="http://schemas.microsoft.com/office/drawing/2014/main" val="10002"/>
+                  </a:ext>
+                </a:extLst>
               </a:tr>
             </a:tbl>
           </a:graphicData>
@@ -9217,7 +9253,7 @@
           </a:bodyPr>
           <a:lstStyle/>
           <a:p>
-            <a:pPr algn="l" indent="0" marL="0">
+            <a:pPr marL="0" indent="0" algn="l">
               <a:lnSpc>
                 <a:spcPts val="1680"/>
               </a:lnSpc>
@@ -9261,7 +9297,7 @@
           </a:bodyPr>
           <a:lstStyle/>
           <a:p>
-            <a:pPr algn="l" indent="0" marL="0">
+            <a:pPr marL="0" indent="0" algn="l">
               <a:lnSpc>
                 <a:spcPts val="1680"/>
               </a:lnSpc>
@@ -9305,7 +9341,7 @@
           </a:bodyPr>
           <a:lstStyle/>
           <a:p>
-            <a:pPr algn="l" indent="0" marL="0">
+            <a:pPr marL="0" indent="0" algn="l">
               <a:lnSpc>
                 <a:spcPts val="1680"/>
               </a:lnSpc>
@@ -9349,7 +9385,7 @@
           </a:bodyPr>
           <a:lstStyle/>
           <a:p>
-            <a:pPr algn="r" indent="0" marL="0">
+            <a:pPr marL="0" indent="0" algn="r">
               <a:lnSpc>
                 <a:spcPts val="1680"/>
               </a:lnSpc>
@@ -9386,6 +9422,7 @@
         <a:solidFill>
           <a:srgbClr val="F6F5F1"/>
         </a:solidFill>
+        <a:effectLst/>
       </p:bgPr>
     </p:bg>
     <p:spTree>
@@ -9425,14 +9462,14 @@
           </a:bodyPr>
           <a:lstStyle/>
           <a:p>
-            <a:pPr algn="l" indent="0" marL="0">
+            <a:pPr marL="0" indent="0" algn="l">
               <a:lnSpc>
                 <a:spcPts val="1680"/>
               </a:lnSpc>
               <a:buNone/>
             </a:pPr>
             <a:r>
-              <a:rPr lang="en-US" sz="1200" b="1" spc="100" kern="0" dirty="0">
+              <a:rPr lang="en-US" sz="1200" b="1" kern="0" spc="100" dirty="0">
                 <a:solidFill>
                   <a:srgbClr val="B34A18"/>
                 </a:solidFill>
@@ -9449,7 +9486,9 @@
       <p:sp>
         <p:nvSpPr>
           <p:cNvPr id="3" name="Text 1"/>
-          <p:cNvSpPr/>
+          <p:cNvSpPr>
+            <a:spLocks noGrp="1"/>
+          </p:cNvSpPr>
           <p:nvPr>
             <p:ph type="title"/>
           </p:nvPr>
@@ -9471,7 +9510,7 @@
           </a:bodyPr>
           <a:lstStyle/>
           <a:p>
-            <a:pPr algn="l" indent="0" marL="0">
+            <a:pPr marL="0" indent="0" algn="l">
               <a:lnSpc>
                 <a:spcPts val="3520"/>
               </a:lnSpc>
@@ -9518,6 +9557,13 @@
             <a:prstDash val="solid"/>
           </a:ln>
         </p:spPr>
+        <p:txBody>
+          <a:bodyPr/>
+          <a:lstStyle/>
+          <a:p>
+            <a:endParaRPr lang="es-CL"/>
+          </a:p>
+        </p:txBody>
       </p:sp>
       <p:sp>
         <p:nvSpPr>
@@ -9542,7 +9588,7 @@
           </a:bodyPr>
           <a:lstStyle/>
           <a:p>
-            <a:pPr algn="l" indent="0" marL="0">
+            <a:pPr marL="0" indent="0" algn="l">
               <a:lnSpc>
                 <a:spcPts val="1800"/>
               </a:lnSpc>
@@ -9586,7 +9632,7 @@
           </a:bodyPr>
           <a:lstStyle/>
           <a:p>
-            <a:pPr algn="l" indent="0" marL="0">
+            <a:pPr marL="0" indent="0" algn="l">
               <a:lnSpc>
                 <a:spcPts val="1680"/>
               </a:lnSpc>
@@ -9609,15 +9655,15 @@
       </p:sp>
       <p:pic>
         <p:nvPicPr>
-          <p:cNvPr id="7" name="Image 0" descr="arrow-right">    </p:cNvPr>
+          <p:cNvPr id="7" name="Image 0" descr="arrow-right"/>
           <p:cNvPicPr>
             <a:picLocks noChangeAspect="1"/>
           </p:cNvPicPr>
           <p:nvPr/>
         </p:nvPicPr>
         <p:blipFill>
-          <a:blip r:embed="rId1"/>
-          <a:srcRect l="0" r="0" t="0" b="0"/>
+          <a:blip r:embed="rId3"/>
+          <a:srcRect/>
           <a:stretch/>
         </p:blipFill>
         <p:spPr>
@@ -9656,6 +9702,13 @@
             <a:prstDash val="solid"/>
           </a:ln>
         </p:spPr>
+        <p:txBody>
+          <a:bodyPr/>
+          <a:lstStyle/>
+          <a:p>
+            <a:endParaRPr lang="es-CL"/>
+          </a:p>
+        </p:txBody>
       </p:sp>
       <p:sp>
         <p:nvSpPr>
@@ -9680,7 +9733,7 @@
           </a:bodyPr>
           <a:lstStyle/>
           <a:p>
-            <a:pPr algn="l" indent="0" marL="0">
+            <a:pPr marL="0" indent="0" algn="l">
               <a:lnSpc>
                 <a:spcPts val="1800"/>
               </a:lnSpc>
@@ -9724,7 +9777,7 @@
           </a:bodyPr>
           <a:lstStyle/>
           <a:p>
-            <a:pPr algn="l" indent="0" marL="0">
+            <a:pPr marL="0" indent="0" algn="l">
               <a:lnSpc>
                 <a:spcPts val="1680"/>
               </a:lnSpc>
@@ -9747,15 +9800,15 @@
       </p:sp>
       <p:pic>
         <p:nvPicPr>
-          <p:cNvPr id="11" name="Image 1" descr="arrow-right">    </p:cNvPr>
+          <p:cNvPr id="11" name="Image 1" descr="arrow-right"/>
           <p:cNvPicPr>
             <a:picLocks noChangeAspect="1"/>
           </p:cNvPicPr>
           <p:nvPr/>
         </p:nvPicPr>
         <p:blipFill>
-          <a:blip r:embed="rId2"/>
-          <a:srcRect l="0" r="0" t="0" b="0"/>
+          <a:blip r:embed="rId3"/>
+          <a:srcRect/>
           <a:stretch/>
         </p:blipFill>
         <p:spPr>
@@ -9794,6 +9847,13 @@
             <a:prstDash val="solid"/>
           </a:ln>
         </p:spPr>
+        <p:txBody>
+          <a:bodyPr/>
+          <a:lstStyle/>
+          <a:p>
+            <a:endParaRPr lang="es-CL"/>
+          </a:p>
+        </p:txBody>
       </p:sp>
       <p:sp>
         <p:nvSpPr>
@@ -9818,7 +9878,7 @@
           </a:bodyPr>
           <a:lstStyle/>
           <a:p>
-            <a:pPr algn="l" indent="0" marL="0">
+            <a:pPr marL="0" indent="0" algn="l">
               <a:lnSpc>
                 <a:spcPts val="1800"/>
               </a:lnSpc>
@@ -9862,7 +9922,7 @@
           </a:bodyPr>
           <a:lstStyle/>
           <a:p>
-            <a:pPr algn="l" indent="0" marL="0">
+            <a:pPr marL="0" indent="0" algn="l">
               <a:lnSpc>
                 <a:spcPts val="1680"/>
               </a:lnSpc>
@@ -9885,7 +9945,7 @@
       </p:sp>
       <p:pic>
         <p:nvPicPr>
-          <p:cNvPr id="15" name="Image 2" descr="arrow-right">    </p:cNvPr>
+          <p:cNvPr id="15" name="Image 2" descr="arrow-right"/>
           <p:cNvPicPr>
             <a:picLocks noChangeAspect="1"/>
           </p:cNvPicPr>
@@ -9893,7 +9953,7 @@
         </p:nvPicPr>
         <p:blipFill>
           <a:blip r:embed="rId3"/>
-          <a:srcRect l="0" r="0" t="0" b="0"/>
+          <a:srcRect/>
           <a:stretch/>
         </p:blipFill>
         <p:spPr>
@@ -9932,6 +9992,13 @@
             <a:prstDash val="solid"/>
           </a:ln>
         </p:spPr>
+        <p:txBody>
+          <a:bodyPr/>
+          <a:lstStyle/>
+          <a:p>
+            <a:endParaRPr lang="es-CL"/>
+          </a:p>
+        </p:txBody>
       </p:sp>
       <p:sp>
         <p:nvSpPr>
@@ -9956,7 +10023,7 @@
           </a:bodyPr>
           <a:lstStyle/>
           <a:p>
-            <a:pPr algn="l" indent="0" marL="0">
+            <a:pPr marL="0" indent="0" algn="l">
               <a:lnSpc>
                 <a:spcPts val="1800"/>
               </a:lnSpc>
@@ -10000,7 +10067,7 @@
           </a:bodyPr>
           <a:lstStyle/>
           <a:p>
-            <a:pPr algn="l" indent="0" marL="0">
+            <a:pPr marL="0" indent="0" algn="l">
               <a:lnSpc>
                 <a:spcPts val="1680"/>
               </a:lnSpc>
@@ -10043,6 +10110,13 @@
             <a:prstDash val="solid"/>
           </a:ln>
         </p:spPr>
+        <p:txBody>
+          <a:bodyPr/>
+          <a:lstStyle/>
+          <a:p>
+            <a:endParaRPr lang="es-CL"/>
+          </a:p>
+        </p:txBody>
       </p:sp>
       <p:sp>
         <p:nvSpPr>
@@ -10067,7 +10141,7 @@
           </a:bodyPr>
           <a:lstStyle/>
           <a:p>
-            <a:pPr algn="l" indent="0" marL="0">
+            <a:pPr marL="0" indent="0" algn="l">
               <a:lnSpc>
                 <a:spcPts val="1800"/>
               </a:lnSpc>
@@ -10111,7 +10185,7 @@
           </a:bodyPr>
           <a:lstStyle/>
           <a:p>
-            <a:pPr algn="l" indent="0" marL="0">
+            <a:pPr marL="0" indent="0" algn="l">
               <a:lnSpc>
                 <a:spcPts val="1680"/>
               </a:lnSpc>
@@ -10155,7 +10229,7 @@
           </a:bodyPr>
           <a:lstStyle/>
           <a:p>
-            <a:pPr algn="l" indent="0" marL="0">
+            <a:pPr marL="0" indent="0" algn="l">
               <a:lnSpc>
                 <a:spcPts val="1680"/>
               </a:lnSpc>
@@ -10199,7 +10273,7 @@
           </a:bodyPr>
           <a:lstStyle/>
           <a:p>
-            <a:pPr algn="l" indent="0" marL="0">
+            <a:pPr marL="0" indent="0" algn="l">
               <a:lnSpc>
                 <a:spcPts val="1680"/>
               </a:lnSpc>
@@ -10243,7 +10317,7 @@
           </a:bodyPr>
           <a:lstStyle/>
           <a:p>
-            <a:pPr algn="l" indent="0" marL="0">
+            <a:pPr marL="0" indent="0" algn="l">
               <a:lnSpc>
                 <a:spcPts val="1680"/>
               </a:lnSpc>
@@ -10287,7 +10361,7 @@
           </a:bodyPr>
           <a:lstStyle/>
           <a:p>
-            <a:pPr algn="l" indent="0" marL="0">
+            <a:pPr marL="0" indent="0" algn="l">
               <a:lnSpc>
                 <a:spcPts val="1680"/>
               </a:lnSpc>
@@ -10331,7 +10405,7 @@
           </a:bodyPr>
           <a:lstStyle/>
           <a:p>
-            <a:pPr algn="l" indent="0" marL="0">
+            <a:pPr marL="0" indent="0" algn="l">
               <a:lnSpc>
                 <a:spcPts val="1680"/>
               </a:lnSpc>
@@ -10375,7 +10449,7 @@
           </a:bodyPr>
           <a:lstStyle/>
           <a:p>
-            <a:pPr algn="l" indent="0" marL="0">
+            <a:pPr marL="0" indent="0" algn="l">
               <a:lnSpc>
                 <a:spcPts val="1680"/>
               </a:lnSpc>
@@ -10419,7 +10493,7 @@
           </a:bodyPr>
           <a:lstStyle/>
           <a:p>
-            <a:pPr algn="r" indent="0" marL="0">
+            <a:pPr marL="0" indent="0" algn="r">
               <a:lnSpc>
                 <a:spcPts val="1680"/>
               </a:lnSpc>
@@ -10456,6 +10530,7 @@
         <a:solidFill>
           <a:srgbClr val="F6F5F1"/>
         </a:solidFill>
+        <a:effectLst/>
       </p:bgPr>
     </p:bg>
     <p:spTree>
@@ -10495,14 +10570,14 @@
           </a:bodyPr>
           <a:lstStyle/>
           <a:p>
-            <a:pPr algn="l" indent="0" marL="0">
+            <a:pPr marL="0" indent="0" algn="l">
               <a:lnSpc>
                 <a:spcPts val="1680"/>
               </a:lnSpc>
               <a:buNone/>
             </a:pPr>
             <a:r>
-              <a:rPr lang="en-US" sz="1200" b="1" spc="100" kern="0" dirty="0">
+              <a:rPr lang="en-US" sz="1200" b="1" kern="0" spc="100" dirty="0">
                 <a:solidFill>
                   <a:srgbClr val="B34A18"/>
                 </a:solidFill>
@@ -10519,7 +10594,9 @@
       <p:sp>
         <p:nvSpPr>
           <p:cNvPr id="3" name="Text 1"/>
-          <p:cNvSpPr/>
+          <p:cNvSpPr>
+            <a:spLocks noGrp="1"/>
+          </p:cNvSpPr>
           <p:nvPr>
             <p:ph type="title"/>
           </p:nvPr>
@@ -10541,7 +10618,7 @@
           </a:bodyPr>
           <a:lstStyle/>
           <a:p>
-            <a:pPr algn="l" indent="0" marL="0">
+            <a:pPr marL="0" indent="0" algn="l">
               <a:lnSpc>
                 <a:spcPts val="3520"/>
               </a:lnSpc>
@@ -10585,7 +10662,7 @@
           </a:bodyPr>
           <a:lstStyle/>
           <a:p>
-            <a:pPr algn="l" indent="0" marL="0">
+            <a:pPr marL="0" indent="0" algn="l">
               <a:lnSpc>
                 <a:spcPts val="1680"/>
               </a:lnSpc>
@@ -10629,7 +10706,7 @@
           </a:bodyPr>
           <a:lstStyle/>
           <a:p>
-            <a:pPr algn="l" indent="0" marL="0">
+            <a:pPr marL="0" indent="0" algn="l">
               <a:lnSpc>
                 <a:spcPts val="2400"/>
               </a:lnSpc>
@@ -10673,7 +10750,7 @@
           </a:bodyPr>
           <a:lstStyle/>
           <a:p>
-            <a:pPr algn="l" indent="0" marL="0">
+            <a:pPr marL="0" indent="0" algn="l">
               <a:lnSpc>
                 <a:spcPts val="2400"/>
               </a:lnSpc>
@@ -10717,7 +10794,7 @@
           </a:bodyPr>
           <a:lstStyle/>
           <a:p>
-            <a:pPr algn="l" indent="0" marL="0">
+            <a:pPr marL="0" indent="0" algn="l">
               <a:lnSpc>
                 <a:spcPts val="2400"/>
               </a:lnSpc>
@@ -10761,7 +10838,7 @@
           </a:bodyPr>
           <a:lstStyle/>
           <a:p>
-            <a:pPr algn="l" indent="0" marL="0">
+            <a:pPr marL="0" indent="0" algn="l">
               <a:lnSpc>
                 <a:spcPts val="2400"/>
               </a:lnSpc>
@@ -10805,7 +10882,7 @@
           </a:bodyPr>
           <a:lstStyle/>
           <a:p>
-            <a:pPr algn="l" indent="0" marL="0">
+            <a:pPr marL="0" indent="0" algn="l">
               <a:lnSpc>
                 <a:spcPts val="2400"/>
               </a:lnSpc>
@@ -10848,6 +10925,13 @@
             <a:prstDash val="solid"/>
           </a:ln>
         </p:spPr>
+        <p:txBody>
+          <a:bodyPr/>
+          <a:lstStyle/>
+          <a:p>
+            <a:endParaRPr lang="es-CL"/>
+          </a:p>
+        </p:txBody>
       </p:sp>
       <p:sp>
         <p:nvSpPr>
@@ -10868,6 +10952,13 @@
           </a:solidFill>
           <a:ln/>
         </p:spPr>
+        <p:txBody>
+          <a:bodyPr/>
+          <a:lstStyle/>
+          <a:p>
+            <a:endParaRPr lang="es-CL"/>
+          </a:p>
+        </p:txBody>
       </p:sp>
       <p:sp>
         <p:nvSpPr>
@@ -10892,7 +10983,7 @@
           </a:bodyPr>
           <a:lstStyle/>
           <a:p>
-            <a:pPr algn="l" indent="0" marL="0">
+            <a:pPr marL="0" indent="0" algn="l">
               <a:lnSpc>
                 <a:spcPts val="2100"/>
               </a:lnSpc>
@@ -10932,6 +11023,13 @@
           </a:solidFill>
           <a:ln/>
         </p:spPr>
+        <p:txBody>
+          <a:bodyPr/>
+          <a:lstStyle/>
+          <a:p>
+            <a:endParaRPr lang="es-CL"/>
+          </a:p>
+        </p:txBody>
       </p:sp>
       <p:sp>
         <p:nvSpPr>
@@ -10956,7 +11054,7 @@
           </a:bodyPr>
           <a:lstStyle/>
           <a:p>
-            <a:pPr algn="l" indent="0" marL="0">
+            <a:pPr marL="0" indent="0" algn="l">
               <a:lnSpc>
                 <a:spcPts val="2100"/>
               </a:lnSpc>
@@ -10996,6 +11094,13 @@
           </a:solidFill>
           <a:ln/>
         </p:spPr>
+        <p:txBody>
+          <a:bodyPr/>
+          <a:lstStyle/>
+          <a:p>
+            <a:endParaRPr lang="es-CL"/>
+          </a:p>
+        </p:txBody>
       </p:sp>
       <p:sp>
         <p:nvSpPr>
@@ -11020,7 +11125,7 @@
           </a:bodyPr>
           <a:lstStyle/>
           <a:p>
-            <a:pPr algn="l" indent="0" marL="0">
+            <a:pPr marL="0" indent="0" algn="l">
               <a:lnSpc>
                 <a:spcPts val="2100"/>
               </a:lnSpc>
@@ -11060,6 +11165,13 @@
           </a:solidFill>
           <a:ln/>
         </p:spPr>
+        <p:txBody>
+          <a:bodyPr/>
+          <a:lstStyle/>
+          <a:p>
+            <a:endParaRPr lang="es-CL"/>
+          </a:p>
+        </p:txBody>
       </p:sp>
       <p:sp>
         <p:nvSpPr>
@@ -11084,7 +11196,7 @@
           </a:bodyPr>
           <a:lstStyle/>
           <a:p>
-            <a:pPr algn="l" indent="0" marL="0">
+            <a:pPr marL="0" indent="0" algn="l">
               <a:lnSpc>
                 <a:spcPts val="2100"/>
               </a:lnSpc>
@@ -11124,6 +11236,13 @@
           </a:solidFill>
           <a:ln/>
         </p:spPr>
+        <p:txBody>
+          <a:bodyPr/>
+          <a:lstStyle/>
+          <a:p>
+            <a:endParaRPr lang="es-CL"/>
+          </a:p>
+        </p:txBody>
       </p:sp>
       <p:sp>
         <p:nvSpPr>
@@ -11148,7 +11267,7 @@
           </a:bodyPr>
           <a:lstStyle/>
           <a:p>
-            <a:pPr algn="l" indent="0" marL="0">
+            <a:pPr marL="0" indent="0" algn="l">
               <a:lnSpc>
                 <a:spcPts val="2100"/>
               </a:lnSpc>
@@ -11192,7 +11311,7 @@
           </a:bodyPr>
           <a:lstStyle/>
           <a:p>
-            <a:pPr algn="l" indent="0" marL="0">
+            <a:pPr marL="0" indent="0" algn="l">
               <a:lnSpc>
                 <a:spcPts val="1680"/>
               </a:lnSpc>
@@ -11236,9 +11355,27 @@
             <a:tbl>
               <a:tblPr/>
               <a:tblGrid>
-                <a:gridCol w="1925320"/>
-                <a:gridCol w="1443990"/>
-                <a:gridCol w="1443990"/>
+                <a:gridCol w="1925320">
+                  <a:extLst>
+                    <a:ext uri="{9D8B030D-6E8A-4147-A177-3AD203B41FA5}">
+                      <a16:colId xmlns:a16="http://schemas.microsoft.com/office/drawing/2014/main" val="20000"/>
+                    </a:ext>
+                  </a:extLst>
+                </a:gridCol>
+                <a:gridCol w="1443990">
+                  <a:extLst>
+                    <a:ext uri="{9D8B030D-6E8A-4147-A177-3AD203B41FA5}">
+                      <a16:colId xmlns:a16="http://schemas.microsoft.com/office/drawing/2014/main" val="20001"/>
+                    </a:ext>
+                  </a:extLst>
+                </a:gridCol>
+                <a:gridCol w="1443990">
+                  <a:extLst>
+                    <a:ext uri="{9D8B030D-6E8A-4147-A177-3AD203B41FA5}">
+                      <a16:colId xmlns:a16="http://schemas.microsoft.com/office/drawing/2014/main" val="20002"/>
+                    </a:ext>
+                  </a:extLst>
+                </a:gridCol>
               </a:tblGrid>
               <a:tr h="412750">
                 <a:tc>
@@ -11246,7 +11383,7 @@
                     <a:bodyPr/>
                     <a:lstStyle/>
                     <a:p>
-                      <a:pPr indent="0" marL="0">
+                      <a:pPr marL="0" indent="0">
                         <a:lnSpc>
                           <a:spcPts val="2100"/>
                         </a:lnSpc>
@@ -11270,7 +11407,7 @@
                       </a:endParaRPr>
                     </a:p>
                   </a:txBody>
-                  <a:tcPr marL="66675" marR="66675" marT="66675" marB="66675" anchor="t">
+                  <a:tcPr marL="66675" marR="66675" marT="66675" marB="66675">
                     <a:lnL w="12700" cap="flat" cmpd="sng" algn="ctr">
                       <a:solidFill>
                         <a:srgbClr val="C4C4C0"/>
@@ -11317,7 +11454,7 @@
                     <a:bodyPr/>
                     <a:lstStyle/>
                     <a:p>
-                      <a:pPr algn="r" indent="0" marL="0">
+                      <a:pPr marL="0" indent="0" algn="r">
                         <a:lnSpc>
                           <a:spcPts val="2100"/>
                         </a:lnSpc>
@@ -11341,7 +11478,7 @@
                       </a:endParaRPr>
                     </a:p>
                   </a:txBody>
-                  <a:tcPr marL="66675" marR="66675" marT="66675" marB="66675" anchor="t">
+                  <a:tcPr marL="66675" marR="66675" marT="66675" marB="66675">
                     <a:lnL w="12700" cap="flat" cmpd="sng" algn="ctr">
                       <a:solidFill>
                         <a:srgbClr val="B6B5B2"/>
@@ -11388,7 +11525,7 @@
                     <a:bodyPr/>
                     <a:lstStyle/>
                     <a:p>
-                      <a:pPr algn="r" indent="0" marL="0">
+                      <a:pPr marL="0" indent="0" algn="r">
                         <a:lnSpc>
                           <a:spcPts val="2100"/>
                         </a:lnSpc>
@@ -11412,7 +11549,7 @@
                       </a:endParaRPr>
                     </a:p>
                   </a:txBody>
-                  <a:tcPr marL="66675" marR="66675" marT="66675" marB="66675" anchor="t">
+                  <a:tcPr marL="66675" marR="66675" marT="66675" marB="66675">
                     <a:lnL w="12700" cap="flat" cmpd="sng" algn="ctr">
                       <a:solidFill>
                         <a:srgbClr val="B6B5B2"/>
@@ -11454,6 +11591,11 @@
                     </a:solidFill>
                   </a:tcPr>
                 </a:tc>
+                <a:extLst>
+                  <a:ext uri="{0D108BD9-81ED-4DB2-BD59-A6C34878D82A}">
+                    <a16:rowId xmlns:a16="http://schemas.microsoft.com/office/drawing/2014/main" val="10000"/>
+                  </a:ext>
+                </a:extLst>
               </a:tr>
               <a:tr h="412750">
                 <a:tc>
@@ -11461,7 +11603,7 @@
                     <a:bodyPr/>
                     <a:lstStyle/>
                     <a:p>
-                      <a:pPr indent="0" marL="0">
+                      <a:pPr marL="0" indent="0">
                         <a:lnSpc>
                           <a:spcPts val="2100"/>
                         </a:lnSpc>
@@ -11485,7 +11627,7 @@
                       </a:endParaRPr>
                     </a:p>
                   </a:txBody>
-                  <a:tcPr marL="66675" marR="66675" marT="66675" marB="66675" anchor="t">
+                  <a:tcPr marL="66675" marR="66675" marT="66675" marB="66675">
                     <a:lnL w="12700" cap="flat" cmpd="sng" algn="ctr">
                       <a:solidFill>
                         <a:srgbClr val="C4C4C0"/>
@@ -11529,7 +11671,7 @@
                     <a:bodyPr/>
                     <a:lstStyle/>
                     <a:p>
-                      <a:pPr algn="r" indent="0" marL="0">
+                      <a:pPr marL="0" indent="0" algn="r">
                         <a:lnSpc>
                           <a:spcPts val="2100"/>
                         </a:lnSpc>
@@ -11553,7 +11695,7 @@
                       </a:endParaRPr>
                     </a:p>
                   </a:txBody>
-                  <a:tcPr marL="66675" marR="66675" marT="66675" marB="66675" anchor="t">
+                  <a:tcPr marL="66675" marR="66675" marT="66675" marB="66675">
                     <a:lnL w="12700" cap="flat" cmpd="sng" algn="ctr">
                       <a:solidFill>
                         <a:srgbClr val="C4C4C0"/>
@@ -11597,7 +11739,7 @@
                     <a:bodyPr/>
                     <a:lstStyle/>
                     <a:p>
-                      <a:pPr algn="r" indent="0" marL="0">
+                      <a:pPr marL="0" indent="0" algn="r">
                         <a:lnSpc>
                           <a:spcPts val="2100"/>
                         </a:lnSpc>
@@ -11621,7 +11763,7 @@
                       </a:endParaRPr>
                     </a:p>
                   </a:txBody>
-                  <a:tcPr marL="66675" marR="66675" marT="66675" marB="66675" anchor="t">
+                  <a:tcPr marL="66675" marR="66675" marT="66675" marB="66675">
                     <a:lnL w="12700" cap="flat" cmpd="sng" algn="ctr">
                       <a:solidFill>
                         <a:srgbClr val="C4C4C0"/>
@@ -11660,6 +11802,11 @@
                     </a:lnB>
                   </a:tcPr>
                 </a:tc>
+                <a:extLst>
+                  <a:ext uri="{0D108BD9-81ED-4DB2-BD59-A6C34878D82A}">
+                    <a16:rowId xmlns:a16="http://schemas.microsoft.com/office/drawing/2014/main" val="10001"/>
+                  </a:ext>
+                </a:extLst>
               </a:tr>
               <a:tr h="412750">
                 <a:tc>
@@ -11667,7 +11814,7 @@
                     <a:bodyPr/>
                     <a:lstStyle/>
                     <a:p>
-                      <a:pPr indent="0" marL="0">
+                      <a:pPr marL="0" indent="0">
                         <a:lnSpc>
                           <a:spcPts val="2100"/>
                         </a:lnSpc>
@@ -11691,7 +11838,7 @@
                       </a:endParaRPr>
                     </a:p>
                   </a:txBody>
-                  <a:tcPr marL="66675" marR="66675" marT="66675" marB="66675" anchor="t">
+                  <a:tcPr marL="66675" marR="66675" marT="66675" marB="66675">
                     <a:lnL w="12700" cap="flat" cmpd="sng" algn="ctr">
                       <a:solidFill>
                         <a:srgbClr val="C4C4C0"/>
@@ -11735,7 +11882,7 @@
                     <a:bodyPr/>
                     <a:lstStyle/>
                     <a:p>
-                      <a:pPr algn="r" indent="0" marL="0">
+                      <a:pPr marL="0" indent="0" algn="r">
                         <a:lnSpc>
                           <a:spcPts val="2100"/>
                         </a:lnSpc>
@@ -11759,7 +11906,7 @@
                       </a:endParaRPr>
                     </a:p>
                   </a:txBody>
-                  <a:tcPr marL="66675" marR="66675" marT="66675" marB="66675" anchor="t">
+                  <a:tcPr marL="66675" marR="66675" marT="66675" marB="66675">
                     <a:lnL w="12700" cap="flat" cmpd="sng" algn="ctr">
                       <a:solidFill>
                         <a:srgbClr val="C4C4C0"/>
@@ -11803,7 +11950,7 @@
                     <a:bodyPr/>
                     <a:lstStyle/>
                     <a:p>
-                      <a:pPr algn="r" indent="0" marL="0">
+                      <a:pPr marL="0" indent="0" algn="r">
                         <a:lnSpc>
                           <a:spcPts val="2100"/>
                         </a:lnSpc>
@@ -11827,7 +11974,7 @@
                       </a:endParaRPr>
                     </a:p>
                   </a:txBody>
-                  <a:tcPr marL="66675" marR="66675" marT="66675" marB="66675" anchor="t">
+                  <a:tcPr marL="66675" marR="66675" marT="66675" marB="66675">
                     <a:lnL w="12700" cap="flat" cmpd="sng" algn="ctr">
                       <a:solidFill>
                         <a:srgbClr val="C4C4C0"/>
@@ -11866,6 +12013,11 @@
                     </a:lnB>
                   </a:tcPr>
                 </a:tc>
+                <a:extLst>
+                  <a:ext uri="{0D108BD9-81ED-4DB2-BD59-A6C34878D82A}">
+                    <a16:rowId xmlns:a16="http://schemas.microsoft.com/office/drawing/2014/main" val="10002"/>
+                  </a:ext>
+                </a:extLst>
               </a:tr>
               <a:tr h="412750">
                 <a:tc>
@@ -11873,7 +12025,7 @@
                     <a:bodyPr/>
                     <a:lstStyle/>
                     <a:p>
-                      <a:pPr indent="0" marL="0">
+                      <a:pPr marL="0" indent="0">
                         <a:lnSpc>
                           <a:spcPts val="2100"/>
                         </a:lnSpc>
@@ -11897,7 +12049,7 @@
                       </a:endParaRPr>
                     </a:p>
                   </a:txBody>
-                  <a:tcPr marL="66675" marR="66675" marT="66675" marB="66675" anchor="t">
+                  <a:tcPr marL="66675" marR="66675" marT="66675" marB="66675">
                     <a:lnL w="12700" cap="flat" cmpd="sng" algn="ctr">
                       <a:solidFill>
                         <a:srgbClr val="C4C4C0"/>
@@ -11941,7 +12093,7 @@
                     <a:bodyPr/>
                     <a:lstStyle/>
                     <a:p>
-                      <a:pPr algn="r" indent="0" marL="0">
+                      <a:pPr marL="0" indent="0" algn="r">
                         <a:lnSpc>
                           <a:spcPts val="2100"/>
                         </a:lnSpc>
@@ -11965,7 +12117,7 @@
                       </a:endParaRPr>
                     </a:p>
                   </a:txBody>
-                  <a:tcPr marL="66675" marR="66675" marT="66675" marB="66675" anchor="t">
+                  <a:tcPr marL="66675" marR="66675" marT="66675" marB="66675">
                     <a:lnL w="12700" cap="flat" cmpd="sng" algn="ctr">
                       <a:solidFill>
                         <a:srgbClr val="C4C4C0"/>
@@ -12009,7 +12161,7 @@
                     <a:bodyPr/>
                     <a:lstStyle/>
                     <a:p>
-                      <a:pPr algn="r" indent="0" marL="0">
+                      <a:pPr marL="0" indent="0" algn="r">
                         <a:lnSpc>
                           <a:spcPts val="2100"/>
                         </a:lnSpc>
@@ -12033,7 +12185,7 @@
                       </a:endParaRPr>
                     </a:p>
                   </a:txBody>
-                  <a:tcPr marL="66675" marR="66675" marT="66675" marB="66675" anchor="t">
+                  <a:tcPr marL="66675" marR="66675" marT="66675" marB="66675">
                     <a:lnL w="12700" cap="flat" cmpd="sng" algn="ctr">
                       <a:solidFill>
                         <a:srgbClr val="C4C4C0"/>
@@ -12072,6 +12224,11 @@
                     </a:lnB>
                   </a:tcPr>
                 </a:tc>
+                <a:extLst>
+                  <a:ext uri="{0D108BD9-81ED-4DB2-BD59-A6C34878D82A}">
+                    <a16:rowId xmlns:a16="http://schemas.microsoft.com/office/drawing/2014/main" val="10003"/>
+                  </a:ext>
+                </a:extLst>
               </a:tr>
             </a:tbl>
           </a:graphicData>
@@ -12100,7 +12257,7 @@
           </a:bodyPr>
           <a:lstStyle/>
           <a:p>
-            <a:pPr algn="l" indent="0" marL="0">
+            <a:pPr marL="0" indent="0" algn="l">
               <a:lnSpc>
                 <a:spcPts val="2100"/>
               </a:lnSpc>
@@ -12166,7 +12323,7 @@
           </a:bodyPr>
           <a:lstStyle/>
           <a:p>
-            <a:pPr algn="l" indent="0" marL="0">
+            <a:pPr marL="0" indent="0" algn="l">
               <a:lnSpc>
                 <a:spcPts val="1680"/>
               </a:lnSpc>
@@ -12210,7 +12367,7 @@
           </a:bodyPr>
           <a:lstStyle/>
           <a:p>
-            <a:pPr algn="l" indent="0" marL="0">
+            <a:pPr marL="0" indent="0" algn="l">
               <a:lnSpc>
                 <a:spcPts val="1680"/>
               </a:lnSpc>
@@ -12254,7 +12411,7 @@
           </a:bodyPr>
           <a:lstStyle/>
           <a:p>
-            <a:pPr algn="r" indent="0" marL="0">
+            <a:pPr marL="0" indent="0" algn="r">
               <a:lnSpc>
                 <a:spcPts val="1680"/>
               </a:lnSpc>
@@ -12291,6 +12448,7 @@
         <a:solidFill>
           <a:srgbClr val="F6F5F1"/>
         </a:solidFill>
+        <a:effectLst/>
       </p:bgPr>
     </p:bg>
     <p:spTree>
@@ -12330,14 +12488,14 @@
           </a:bodyPr>
           <a:lstStyle/>
           <a:p>
-            <a:pPr algn="l" indent="0" marL="0">
+            <a:pPr marL="0" indent="0" algn="l">
               <a:lnSpc>
                 <a:spcPts val="1680"/>
               </a:lnSpc>
               <a:buNone/>
             </a:pPr>
             <a:r>
-              <a:rPr lang="en-US" sz="1200" b="1" spc="100" kern="0" dirty="0">
+              <a:rPr lang="en-US" sz="1200" b="1" kern="0" spc="100" dirty="0">
                 <a:solidFill>
                   <a:srgbClr val="B34A18"/>
                 </a:solidFill>
@@ -12354,7 +12512,9 @@
       <p:sp>
         <p:nvSpPr>
           <p:cNvPr id="3" name="Text 1"/>
-          <p:cNvSpPr/>
+          <p:cNvSpPr>
+            <a:spLocks noGrp="1"/>
+          </p:cNvSpPr>
           <p:nvPr>
             <p:ph type="title"/>
           </p:nvPr>
@@ -12376,7 +12536,7 @@
           </a:bodyPr>
           <a:lstStyle/>
           <a:p>
-            <a:pPr algn="l" indent="0" marL="0">
+            <a:pPr marL="0" indent="0" algn="l">
               <a:lnSpc>
                 <a:spcPts val="3520"/>
               </a:lnSpc>
@@ -12399,15 +12559,15 @@
       </p:sp>
       <p:pic>
         <p:nvPicPr>
-          <p:cNvPr id="4" name="Image 0" descr="Recall y precisión del Random Forest según el umbral de decisión, de 0,10 a 0,80">    </p:cNvPr>
+          <p:cNvPr id="4" name="Image 0" descr="Recall y precisión del Random Forest según el umbral de decisión, de 0,10 a 0,80"/>
           <p:cNvPicPr>
             <a:picLocks noChangeAspect="1"/>
           </p:cNvPicPr>
           <p:nvPr/>
         </p:nvPicPr>
         <p:blipFill>
-          <a:blip r:embed="rId1"/>
-          <a:srcRect l="0" r="0" t="0" b="0"/>
+          <a:blip r:embed="rId3"/>
+          <a:srcRect/>
           <a:stretch/>
         </p:blipFill>
         <p:spPr>
@@ -12443,7 +12603,7 @@
           </a:bodyPr>
           <a:lstStyle/>
           <a:p>
-            <a:pPr algn="ctr" indent="0" marL="0">
+            <a:pPr marL="0" indent="0" algn="ctr">
               <a:lnSpc>
                 <a:spcPts val="1680"/>
               </a:lnSpc>
@@ -12487,7 +12647,7 @@
           </a:bodyPr>
           <a:lstStyle/>
           <a:p>
-            <a:pPr algn="ctr" indent="0" marL="0">
+            <a:pPr marL="0" indent="0" algn="ctr">
               <a:lnSpc>
                 <a:spcPts val="1680"/>
               </a:lnSpc>
@@ -12531,7 +12691,7 @@
           </a:bodyPr>
           <a:lstStyle/>
           <a:p>
-            <a:pPr algn="ctr" indent="0" marL="0">
+            <a:pPr marL="0" indent="0" algn="ctr">
               <a:lnSpc>
                 <a:spcPts val="1680"/>
               </a:lnSpc>
@@ -12575,7 +12735,7 @@
           </a:bodyPr>
           <a:lstStyle/>
           <a:p>
-            <a:pPr algn="ctr" indent="0" marL="0">
+            <a:pPr marL="0" indent="0" algn="ctr">
               <a:lnSpc>
                 <a:spcPts val="1680"/>
               </a:lnSpc>
@@ -12619,7 +12779,7 @@
           </a:bodyPr>
           <a:lstStyle/>
           <a:p>
-            <a:pPr algn="ctr" indent="0" marL="0">
+            <a:pPr marL="0" indent="0" algn="ctr">
               <a:lnSpc>
                 <a:spcPts val="1680"/>
               </a:lnSpc>
@@ -12663,7 +12823,7 @@
           </a:bodyPr>
           <a:lstStyle/>
           <a:p>
-            <a:pPr algn="ctr" indent="0" marL="0">
+            <a:pPr marL="0" indent="0" algn="ctr">
               <a:lnSpc>
                 <a:spcPts val="1680"/>
               </a:lnSpc>
@@ -12707,7 +12867,7 @@
           </a:bodyPr>
           <a:lstStyle/>
           <a:p>
-            <a:pPr algn="ctr" indent="0" marL="0">
+            <a:pPr marL="0" indent="0" algn="ctr">
               <a:lnSpc>
                 <a:spcPts val="1680"/>
               </a:lnSpc>
@@ -12751,7 +12911,7 @@
           </a:bodyPr>
           <a:lstStyle/>
           <a:p>
-            <a:pPr algn="ctr" indent="0" marL="0">
+            <a:pPr marL="0" indent="0" algn="ctr">
               <a:lnSpc>
                 <a:spcPts val="1680"/>
               </a:lnSpc>
@@ -12795,7 +12955,7 @@
           </a:bodyPr>
           <a:lstStyle/>
           <a:p>
-            <a:pPr algn="r" indent="0" marL="0">
+            <a:pPr marL="0" indent="0" algn="r">
               <a:lnSpc>
                 <a:spcPts val="1680"/>
               </a:lnSpc>
@@ -12839,7 +12999,7 @@
           </a:bodyPr>
           <a:lstStyle/>
           <a:p>
-            <a:pPr algn="r" indent="0" marL="0">
+            <a:pPr marL="0" indent="0" algn="r">
               <a:lnSpc>
                 <a:spcPts val="1680"/>
               </a:lnSpc>
@@ -12883,7 +13043,7 @@
           </a:bodyPr>
           <a:lstStyle/>
           <a:p>
-            <a:pPr algn="r" indent="0" marL="0">
+            <a:pPr marL="0" indent="0" algn="r">
               <a:lnSpc>
                 <a:spcPts val="1680"/>
               </a:lnSpc>
@@ -12927,7 +13087,7 @@
           </a:bodyPr>
           <a:lstStyle/>
           <a:p>
-            <a:pPr algn="ctr" indent="0" marL="0">
+            <a:pPr marL="0" indent="0" algn="ctr">
               <a:lnSpc>
                 <a:spcPts val="1680"/>
               </a:lnSpc>
@@ -12971,7 +13131,7 @@
           </a:bodyPr>
           <a:lstStyle/>
           <a:p>
-            <a:pPr algn="l" indent="0" marL="0">
+            <a:pPr marL="0" indent="0" algn="l">
               <a:lnSpc>
                 <a:spcPts val="1680"/>
               </a:lnSpc>
@@ -13015,7 +13175,7 @@
           </a:bodyPr>
           <a:lstStyle/>
           <a:p>
-            <a:pPr algn="l" indent="0" marL="0">
+            <a:pPr marL="0" indent="0" algn="l">
               <a:lnSpc>
                 <a:spcPts val="1680"/>
               </a:lnSpc>
@@ -13059,7 +13219,7 @@
           </a:bodyPr>
           <a:lstStyle/>
           <a:p>
-            <a:pPr algn="l" indent="0" marL="0">
+            <a:pPr marL="0" indent="0" algn="l">
               <a:lnSpc>
                 <a:spcPts val="1680"/>
               </a:lnSpc>
@@ -13103,10 +13263,34 @@
             <a:tbl>
               <a:tblPr/>
               <a:tblGrid>
-                <a:gridCol w="992124"/>
-                <a:gridCol w="850392"/>
-                <a:gridCol w="850392"/>
-                <a:gridCol w="850392"/>
+                <a:gridCol w="992124">
+                  <a:extLst>
+                    <a:ext uri="{9D8B030D-6E8A-4147-A177-3AD203B41FA5}">
+                      <a16:colId xmlns:a16="http://schemas.microsoft.com/office/drawing/2014/main" val="20000"/>
+                    </a:ext>
+                  </a:extLst>
+                </a:gridCol>
+                <a:gridCol w="850392">
+                  <a:extLst>
+                    <a:ext uri="{9D8B030D-6E8A-4147-A177-3AD203B41FA5}">
+                      <a16:colId xmlns:a16="http://schemas.microsoft.com/office/drawing/2014/main" val="20001"/>
+                    </a:ext>
+                  </a:extLst>
+                </a:gridCol>
+                <a:gridCol w="850392">
+                  <a:extLst>
+                    <a:ext uri="{9D8B030D-6E8A-4147-A177-3AD203B41FA5}">
+                      <a16:colId xmlns:a16="http://schemas.microsoft.com/office/drawing/2014/main" val="20002"/>
+                    </a:ext>
+                  </a:extLst>
+                </a:gridCol>
+                <a:gridCol w="850392">
+                  <a:extLst>
+                    <a:ext uri="{9D8B030D-6E8A-4147-A177-3AD203B41FA5}">
+                      <a16:colId xmlns:a16="http://schemas.microsoft.com/office/drawing/2014/main" val="20003"/>
+                    </a:ext>
+                  </a:extLst>
+                </a:gridCol>
               </a:tblGrid>
               <a:tr h="332680">
                 <a:tc>
@@ -13114,7 +13298,7 @@
                     <a:bodyPr/>
                     <a:lstStyle/>
                     <a:p>
-                      <a:pPr indent="0" marL="0">
+                      <a:pPr marL="0" indent="0">
                         <a:lnSpc>
                           <a:spcPts val="1680"/>
                         </a:lnSpc>
@@ -13138,7 +13322,7 @@
                       </a:endParaRPr>
                     </a:p>
                   </a:txBody>
-                  <a:tcPr marL="53340" marR="53340" marT="53340" marB="53340" anchor="t">
+                  <a:tcPr marL="53340" marR="53340" marT="53340" marB="53340">
                     <a:lnL w="12700" cap="flat" cmpd="sng" algn="ctr">
                       <a:solidFill>
                         <a:srgbClr val="C4C4C0"/>
@@ -13185,7 +13369,7 @@
                     <a:bodyPr/>
                     <a:lstStyle/>
                     <a:p>
-                      <a:pPr algn="r" indent="0" marL="0">
+                      <a:pPr marL="0" indent="0" algn="r">
                         <a:lnSpc>
                           <a:spcPts val="1680"/>
                         </a:lnSpc>
@@ -13209,7 +13393,7 @@
                       </a:endParaRPr>
                     </a:p>
                   </a:txBody>
-                  <a:tcPr marL="53340" marR="53340" marT="53340" marB="53340" anchor="t">
+                  <a:tcPr marL="53340" marR="53340" marT="53340" marB="53340">
                     <a:lnL w="12700" cap="flat" cmpd="sng" algn="ctr">
                       <a:solidFill>
                         <a:srgbClr val="B6B5B2"/>
@@ -13256,7 +13440,7 @@
                     <a:bodyPr/>
                     <a:lstStyle/>
                     <a:p>
-                      <a:pPr algn="r" indent="0" marL="0">
+                      <a:pPr marL="0" indent="0" algn="r">
                         <a:lnSpc>
                           <a:spcPts val="1680"/>
                         </a:lnSpc>
@@ -13280,7 +13464,7 @@
                       </a:endParaRPr>
                     </a:p>
                   </a:txBody>
-                  <a:tcPr marL="53340" marR="53340" marT="53340" marB="53340" anchor="t">
+                  <a:tcPr marL="53340" marR="53340" marT="53340" marB="53340">
                     <a:lnL w="12700" cap="flat" cmpd="sng" algn="ctr">
                       <a:solidFill>
                         <a:srgbClr val="B6B5B2"/>
@@ -13327,7 +13511,7 @@
                     <a:bodyPr/>
                     <a:lstStyle/>
                     <a:p>
-                      <a:pPr algn="r" indent="0" marL="0">
+                      <a:pPr marL="0" indent="0" algn="r">
                         <a:lnSpc>
                           <a:spcPts val="1680"/>
                         </a:lnSpc>
@@ -13351,7 +13535,7 @@
                       </a:endParaRPr>
                     </a:p>
                   </a:txBody>
-                  <a:tcPr marL="53340" marR="53340" marT="53340" marB="53340" anchor="t">
+                  <a:tcPr marL="53340" marR="53340" marT="53340" marB="53340">
                     <a:lnL w="12700" cap="flat" cmpd="sng" algn="ctr">
                       <a:solidFill>
                         <a:srgbClr val="B6B5B2"/>
@@ -13393,6 +13577,11 @@
                     </a:solidFill>
                   </a:tcPr>
                 </a:tc>
+                <a:extLst>
+                  <a:ext uri="{0D108BD9-81ED-4DB2-BD59-A6C34878D82A}">
+                    <a16:rowId xmlns:a16="http://schemas.microsoft.com/office/drawing/2014/main" val="10000"/>
+                  </a:ext>
+                </a:extLst>
               </a:tr>
               <a:tr h="332680">
                 <a:tc>
@@ -13400,7 +13589,7 @@
                     <a:bodyPr/>
                     <a:lstStyle/>
                     <a:p>
-                      <a:pPr indent="0" marL="0">
+                      <a:pPr marL="0" indent="0">
                         <a:lnSpc>
                           <a:spcPts val="1680"/>
                         </a:lnSpc>
@@ -13424,7 +13613,7 @@
                       </a:endParaRPr>
                     </a:p>
                   </a:txBody>
-                  <a:tcPr marL="53340" marR="53340" marT="53340" marB="53340" anchor="t">
+                  <a:tcPr marL="53340" marR="53340" marT="53340" marB="53340">
                     <a:lnL w="12700" cap="flat" cmpd="sng" algn="ctr">
                       <a:solidFill>
                         <a:srgbClr val="C4C4C0"/>
@@ -13468,7 +13657,7 @@
                     <a:bodyPr/>
                     <a:lstStyle/>
                     <a:p>
-                      <a:pPr algn="r" indent="0" marL="0">
+                      <a:pPr marL="0" indent="0" algn="r">
                         <a:lnSpc>
                           <a:spcPts val="1680"/>
                         </a:lnSpc>
@@ -13492,7 +13681,7 @@
                       </a:endParaRPr>
                     </a:p>
                   </a:txBody>
-                  <a:tcPr marL="53340" marR="53340" marT="53340" marB="53340" anchor="t">
+                  <a:tcPr marL="53340" marR="53340" marT="53340" marB="53340">
                     <a:lnL w="12700" cap="flat" cmpd="sng" algn="ctr">
                       <a:solidFill>
                         <a:srgbClr val="C4C4C0"/>
@@ -13536,7 +13725,7 @@
                     <a:bodyPr/>
                     <a:lstStyle/>
                     <a:p>
-                      <a:pPr algn="r" indent="0" marL="0">
+                      <a:pPr marL="0" indent="0" algn="r">
                         <a:lnSpc>
                           <a:spcPts val="1680"/>
                         </a:lnSpc>
@@ -13560,7 +13749,7 @@
                       </a:endParaRPr>
                     </a:p>
                   </a:txBody>
-                  <a:tcPr marL="53340" marR="53340" marT="53340" marB="53340" anchor="t">
+                  <a:tcPr marL="53340" marR="53340" marT="53340" marB="53340">
                     <a:lnL w="12700" cap="flat" cmpd="sng" algn="ctr">
                       <a:solidFill>
                         <a:srgbClr val="C4C4C0"/>
@@ -13604,7 +13793,7 @@
                     <a:bodyPr/>
                     <a:lstStyle/>
                     <a:p>
-                      <a:pPr algn="r" indent="0" marL="0">
+                      <a:pPr marL="0" indent="0" algn="r">
                         <a:lnSpc>
                           <a:spcPts val="1680"/>
                         </a:lnSpc>
@@ -13628,7 +13817,7 @@
                       </a:endParaRPr>
                     </a:p>
                   </a:txBody>
-                  <a:tcPr marL="53340" marR="53340" marT="53340" marB="53340" anchor="t">
+                  <a:tcPr marL="53340" marR="53340" marT="53340" marB="53340">
                     <a:lnL w="12700" cap="flat" cmpd="sng" algn="ctr">
                       <a:solidFill>
                         <a:srgbClr val="C4C4C0"/>
@@ -13667,6 +13856,11 @@
                     </a:lnB>
                   </a:tcPr>
                 </a:tc>
+                <a:extLst>
+                  <a:ext uri="{0D108BD9-81ED-4DB2-BD59-A6C34878D82A}">
+                    <a16:rowId xmlns:a16="http://schemas.microsoft.com/office/drawing/2014/main" val="10001"/>
+                  </a:ext>
+                </a:extLst>
               </a:tr>
               <a:tr h="332680">
                 <a:tc>
@@ -13674,7 +13868,7 @@
                     <a:bodyPr/>
                     <a:lstStyle/>
                     <a:p>
-                      <a:pPr indent="0" marL="0">
+                      <a:pPr marL="0" indent="0">
                         <a:lnSpc>
                           <a:spcPts val="1680"/>
                         </a:lnSpc>
@@ -13698,7 +13892,7 @@
                       </a:endParaRPr>
                     </a:p>
                   </a:txBody>
-                  <a:tcPr marL="53340" marR="53340" marT="53340" marB="53340" anchor="t">
+                  <a:tcPr marL="53340" marR="53340" marT="53340" marB="53340">
                     <a:lnL w="12700" cap="flat" cmpd="sng" algn="ctr">
                       <a:solidFill>
                         <a:srgbClr val="C4C4C0"/>
@@ -13742,7 +13936,7 @@
                     <a:bodyPr/>
                     <a:lstStyle/>
                     <a:p>
-                      <a:pPr algn="r" indent="0" marL="0">
+                      <a:pPr marL="0" indent="0" algn="r">
                         <a:lnSpc>
                           <a:spcPts val="1680"/>
                         </a:lnSpc>
@@ -13766,7 +13960,7 @@
                       </a:endParaRPr>
                     </a:p>
                   </a:txBody>
-                  <a:tcPr marL="53340" marR="53340" marT="53340" marB="53340" anchor="t">
+                  <a:tcPr marL="53340" marR="53340" marT="53340" marB="53340">
                     <a:lnL w="12700" cap="flat" cmpd="sng" algn="ctr">
                       <a:solidFill>
                         <a:srgbClr val="C4C4C0"/>
@@ -13810,7 +14004,7 @@
                     <a:bodyPr/>
                     <a:lstStyle/>
                     <a:p>
-                      <a:pPr algn="r" indent="0" marL="0">
+                      <a:pPr marL="0" indent="0" algn="r">
                         <a:lnSpc>
                           <a:spcPts val="1680"/>
                         </a:lnSpc>
@@ -13834,7 +14028,7 @@
                       </a:endParaRPr>
                     </a:p>
                   </a:txBody>
-                  <a:tcPr marL="53340" marR="53340" marT="53340" marB="53340" anchor="t">
+                  <a:tcPr marL="53340" marR="53340" marT="53340" marB="53340">
                     <a:lnL w="12700" cap="flat" cmpd="sng" algn="ctr">
                       <a:solidFill>
                         <a:srgbClr val="C4C4C0"/>
@@ -13878,7 +14072,7 @@
                     <a:bodyPr/>
                     <a:lstStyle/>
                     <a:p>
-                      <a:pPr algn="r" indent="0" marL="0">
+                      <a:pPr marL="0" indent="0" algn="r">
                         <a:lnSpc>
                           <a:spcPts val="1680"/>
                         </a:lnSpc>
@@ -13902,7 +14096,7 @@
                       </a:endParaRPr>
                     </a:p>
                   </a:txBody>
-                  <a:tcPr marL="53340" marR="53340" marT="53340" marB="53340" anchor="t">
+                  <a:tcPr marL="53340" marR="53340" marT="53340" marB="53340">
                     <a:lnL w="12700" cap="flat" cmpd="sng" algn="ctr">
                       <a:solidFill>
                         <a:srgbClr val="C4C4C0"/>
@@ -13941,6 +14135,11 @@
                     </a:lnB>
                   </a:tcPr>
                 </a:tc>
+                <a:extLst>
+                  <a:ext uri="{0D108BD9-81ED-4DB2-BD59-A6C34878D82A}">
+                    <a16:rowId xmlns:a16="http://schemas.microsoft.com/office/drawing/2014/main" val="10002"/>
+                  </a:ext>
+                </a:extLst>
               </a:tr>
               <a:tr h="332680">
                 <a:tc>
@@ -13948,7 +14147,7 @@
                     <a:bodyPr/>
                     <a:lstStyle/>
                     <a:p>
-                      <a:pPr indent="0" marL="0">
+                      <a:pPr marL="0" indent="0">
                         <a:lnSpc>
                           <a:spcPts val="1680"/>
                         </a:lnSpc>
@@ -13972,7 +14171,7 @@
                       </a:endParaRPr>
                     </a:p>
                   </a:txBody>
-                  <a:tcPr marL="53340" marR="53340" marT="53340" marB="53340" anchor="t">
+                  <a:tcPr marL="53340" marR="53340" marT="53340" marB="53340">
                     <a:lnL w="12700" cap="flat" cmpd="sng" algn="ctr">
                       <a:solidFill>
                         <a:srgbClr val="C4C4C0"/>
@@ -14016,7 +14215,7 @@
                     <a:bodyPr/>
                     <a:lstStyle/>
                     <a:p>
-                      <a:pPr algn="r" indent="0" marL="0">
+                      <a:pPr marL="0" indent="0" algn="r">
                         <a:lnSpc>
                           <a:spcPts val="1680"/>
                         </a:lnSpc>
@@ -14040,7 +14239,7 @@
                       </a:endParaRPr>
                     </a:p>
                   </a:txBody>
-                  <a:tcPr marL="53340" marR="53340" marT="53340" marB="53340" anchor="t">
+                  <a:tcPr marL="53340" marR="53340" marT="53340" marB="53340">
                     <a:lnL w="12700" cap="flat" cmpd="sng" algn="ctr">
                       <a:solidFill>
                         <a:srgbClr val="C4C4C0"/>
@@ -14084,7 +14283,7 @@
                     <a:bodyPr/>
                     <a:lstStyle/>
                     <a:p>
-                      <a:pPr algn="r" indent="0" marL="0">
+                      <a:pPr marL="0" indent="0" algn="r">
                         <a:lnSpc>
                           <a:spcPts val="1680"/>
                         </a:lnSpc>
@@ -14108,7 +14307,7 @@
                       </a:endParaRPr>
                     </a:p>
                   </a:txBody>
-                  <a:tcPr marL="53340" marR="53340" marT="53340" marB="53340" anchor="t">
+                  <a:tcPr marL="53340" marR="53340" marT="53340" marB="53340">
                     <a:lnL w="12700" cap="flat" cmpd="sng" algn="ctr">
                       <a:solidFill>
                         <a:srgbClr val="C4C4C0"/>
@@ -14152,7 +14351,7 @@
                     <a:bodyPr/>
                     <a:lstStyle/>
                     <a:p>
-                      <a:pPr algn="r" indent="0" marL="0">
+                      <a:pPr marL="0" indent="0" algn="r">
                         <a:lnSpc>
                           <a:spcPts val="1680"/>
                         </a:lnSpc>
@@ -14176,7 +14375,7 @@
                       </a:endParaRPr>
                     </a:p>
                   </a:txBody>
-                  <a:tcPr marL="53340" marR="53340" marT="53340" marB="53340" anchor="t">
+                  <a:tcPr marL="53340" marR="53340" marT="53340" marB="53340">
                     <a:lnL w="12700" cap="flat" cmpd="sng" algn="ctr">
                       <a:solidFill>
                         <a:srgbClr val="C4C4C0"/>
@@ -14215,6 +14414,11 @@
                     </a:lnB>
                   </a:tcPr>
                 </a:tc>
+                <a:extLst>
+                  <a:ext uri="{0D108BD9-81ED-4DB2-BD59-A6C34878D82A}">
+                    <a16:rowId xmlns:a16="http://schemas.microsoft.com/office/drawing/2014/main" val="10003"/>
+                  </a:ext>
+                </a:extLst>
               </a:tr>
             </a:tbl>
           </a:graphicData>
@@ -14243,7 +14447,7 @@
           </a:bodyPr>
           <a:lstStyle/>
           <a:p>
-            <a:pPr algn="l" indent="0" marL="0">
+            <a:pPr marL="0" indent="0" algn="l">
               <a:lnSpc>
                 <a:spcPts val="1680"/>
               </a:lnSpc>
@@ -14286,6 +14490,13 @@
             <a:prstDash val="solid"/>
           </a:ln>
         </p:spPr>
+        <p:txBody>
+          <a:bodyPr/>
+          <a:lstStyle/>
+          <a:p>
+            <a:endParaRPr lang="es-CL"/>
+          </a:p>
+        </p:txBody>
       </p:sp>
       <p:sp>
         <p:nvSpPr>
@@ -14310,7 +14521,7 @@
           </a:bodyPr>
           <a:lstStyle/>
           <a:p>
-            <a:pPr algn="l" indent="0" marL="0">
+            <a:pPr marL="0" indent="0" algn="l">
               <a:lnSpc>
                 <a:spcPts val="1680"/>
               </a:lnSpc>
@@ -14365,7 +14576,7 @@
           </a:bodyPr>
           <a:lstStyle/>
           <a:p>
-            <a:pPr algn="l" indent="0" marL="0">
+            <a:pPr marL="0" indent="0" algn="l">
               <a:lnSpc>
                 <a:spcPts val="1680"/>
               </a:lnSpc>
@@ -14409,7 +14620,7 @@
           </a:bodyPr>
           <a:lstStyle/>
           <a:p>
-            <a:pPr algn="r" indent="0" marL="0">
+            <a:pPr marL="0" indent="0" algn="r">
               <a:lnSpc>
                 <a:spcPts val="1680"/>
               </a:lnSpc>
@@ -14446,6 +14657,7 @@
         <a:solidFill>
           <a:srgbClr val="F6F5F1"/>
         </a:solidFill>
+        <a:effectLst/>
       </p:bgPr>
     </p:bg>
     <p:spTree>
@@ -14485,14 +14697,14 @@
           </a:bodyPr>
           <a:lstStyle/>
           <a:p>
-            <a:pPr algn="l" indent="0" marL="0">
+            <a:pPr marL="0" indent="0" algn="l">
               <a:lnSpc>
                 <a:spcPts val="1680"/>
               </a:lnSpc>
               <a:buNone/>
             </a:pPr>
             <a:r>
-              <a:rPr lang="en-US" sz="1200" b="1" spc="100" kern="0" dirty="0">
+              <a:rPr lang="en-US" sz="1200" b="1" kern="0" spc="100" dirty="0">
                 <a:solidFill>
                   <a:srgbClr val="B34A18"/>
                 </a:solidFill>
@@ -14509,7 +14721,9 @@
       <p:sp>
         <p:nvSpPr>
           <p:cNvPr id="3" name="Text 1"/>
-          <p:cNvSpPr/>
+          <p:cNvSpPr>
+            <a:spLocks noGrp="1"/>
+          </p:cNvSpPr>
           <p:nvPr>
             <p:ph type="title"/>
           </p:nvPr>
@@ -14531,7 +14745,7 @@
           </a:bodyPr>
           <a:lstStyle/>
           <a:p>
-            <a:pPr algn="l" indent="0" marL="0">
+            <a:pPr marL="0" indent="0" algn="l">
               <a:lnSpc>
                 <a:spcPts val="3520"/>
               </a:lnSpc>
@@ -14578,6 +14792,13 @@
             <a:prstDash val="solid"/>
           </a:ln>
         </p:spPr>
+        <p:txBody>
+          <a:bodyPr/>
+          <a:lstStyle/>
+          <a:p>
+            <a:endParaRPr lang="es-CL"/>
+          </a:p>
+        </p:txBody>
       </p:sp>
       <p:sp>
         <p:nvSpPr>
@@ -14602,7 +14823,7 @@
           </a:bodyPr>
           <a:lstStyle/>
           <a:p>
-            <a:pPr algn="l" indent="0" marL="0">
+            <a:pPr marL="0" indent="0" algn="l">
               <a:lnSpc>
                 <a:spcPts val="1680"/>
               </a:lnSpc>
@@ -14646,7 +14867,7 @@
           </a:bodyPr>
           <a:lstStyle/>
           <a:p>
-            <a:pPr algn="l" indent="0" marL="0">
+            <a:pPr marL="0" indent="0" algn="l">
               <a:lnSpc>
                 <a:spcPts val="3520"/>
               </a:lnSpc>
@@ -14690,7 +14911,7 @@
           </a:bodyPr>
           <a:lstStyle/>
           <a:p>
-            <a:pPr algn="l" indent="0" marL="0">
+            <a:pPr marL="0" indent="0" algn="l">
               <a:lnSpc>
                 <a:spcPts val="1680"/>
               </a:lnSpc>
@@ -14737,6 +14958,13 @@
             <a:prstDash val="solid"/>
           </a:ln>
         </p:spPr>
+        <p:txBody>
+          <a:bodyPr/>
+          <a:lstStyle/>
+          <a:p>
+            <a:endParaRPr lang="es-CL"/>
+          </a:p>
+        </p:txBody>
       </p:sp>
       <p:sp>
         <p:nvSpPr>
@@ -14761,7 +14989,7 @@
           </a:bodyPr>
           <a:lstStyle/>
           <a:p>
-            <a:pPr algn="l" indent="0" marL="0">
+            <a:pPr marL="0" indent="0" algn="l">
               <a:lnSpc>
                 <a:spcPts val="1680"/>
               </a:lnSpc>
@@ -14805,7 +15033,7 @@
           </a:bodyPr>
           <a:lstStyle/>
           <a:p>
-            <a:pPr algn="l" indent="0" marL="0">
+            <a:pPr marL="0" indent="0" algn="l">
               <a:lnSpc>
                 <a:spcPts val="3520"/>
               </a:lnSpc>
@@ -14849,7 +15077,7 @@
           </a:bodyPr>
           <a:lstStyle/>
           <a:p>
-            <a:pPr algn="l" indent="0" marL="0">
+            <a:pPr marL="0" indent="0" algn="l">
               <a:lnSpc>
                 <a:spcPts val="1680"/>
               </a:lnSpc>
@@ -14896,6 +15124,13 @@
             <a:prstDash val="solid"/>
           </a:ln>
         </p:spPr>
+        <p:txBody>
+          <a:bodyPr/>
+          <a:lstStyle/>
+          <a:p>
+            <a:endParaRPr lang="es-CL"/>
+          </a:p>
+        </p:txBody>
       </p:sp>
       <p:sp>
         <p:nvSpPr>
@@ -14920,7 +15155,7 @@
           </a:bodyPr>
           <a:lstStyle/>
           <a:p>
-            <a:pPr algn="l" indent="0" marL="0">
+            <a:pPr marL="0" indent="0" algn="l">
               <a:lnSpc>
                 <a:spcPts val="1680"/>
               </a:lnSpc>
@@ -14964,7 +15199,7 @@
           </a:bodyPr>
           <a:lstStyle/>
           <a:p>
-            <a:pPr algn="l" indent="0" marL="0">
+            <a:pPr marL="0" indent="0" algn="l">
               <a:lnSpc>
                 <a:spcPts val="3520"/>
               </a:lnSpc>
@@ -15008,7 +15243,7 @@
           </a:bodyPr>
           <a:lstStyle/>
           <a:p>
-            <a:pPr algn="l" indent="0" marL="0">
+            <a:pPr marL="0" indent="0" algn="l">
               <a:lnSpc>
                 <a:spcPts val="1680"/>
               </a:lnSpc>
@@ -15055,6 +15290,13 @@
             <a:prstDash val="solid"/>
           </a:ln>
         </p:spPr>
+        <p:txBody>
+          <a:bodyPr/>
+          <a:lstStyle/>
+          <a:p>
+            <a:endParaRPr lang="es-CL"/>
+          </a:p>
+        </p:txBody>
       </p:sp>
       <p:sp>
         <p:nvSpPr>
@@ -15079,7 +15321,7 @@
           </a:bodyPr>
           <a:lstStyle/>
           <a:p>
-            <a:pPr algn="l" indent="0" marL="0">
+            <a:pPr marL="0" indent="0" algn="l">
               <a:lnSpc>
                 <a:spcPts val="1680"/>
               </a:lnSpc>
@@ -15123,7 +15365,7 @@
           </a:bodyPr>
           <a:lstStyle/>
           <a:p>
-            <a:pPr algn="l" indent="0" marL="0">
+            <a:pPr marL="0" indent="0" algn="l">
               <a:lnSpc>
                 <a:spcPts val="3520"/>
               </a:lnSpc>
@@ -15167,7 +15409,7 @@
           </a:bodyPr>
           <a:lstStyle/>
           <a:p>
-            <a:pPr algn="l" indent="0" marL="0">
+            <a:pPr marL="0" indent="0" algn="l">
               <a:lnSpc>
                 <a:spcPts val="1680"/>
               </a:lnSpc>
@@ -15211,7 +15453,7 @@
           </a:bodyPr>
           <a:lstStyle/>
           <a:p>
-            <a:pPr algn="l" indent="0" marL="0">
+            <a:pPr marL="0" indent="0" algn="l">
               <a:lnSpc>
                 <a:spcPts val="2100"/>
               </a:lnSpc>
@@ -15257,7 +15499,7 @@
           </a:bodyPr>
           <a:lstStyle/>
           <a:p>
-            <a:pPr algn="l" indent="0" marL="0">
+            <a:pPr marL="0" indent="0" algn="l">
               <a:lnSpc>
                 <a:spcPts val="2100"/>
               </a:lnSpc>
@@ -15303,7 +15545,7 @@
           </a:bodyPr>
           <a:lstStyle/>
           <a:p>
-            <a:pPr algn="l" indent="0" marL="0">
+            <a:pPr marL="0" indent="0" algn="l">
               <a:lnSpc>
                 <a:spcPts val="2100"/>
               </a:lnSpc>
@@ -15347,7 +15589,7 @@
           </a:bodyPr>
           <a:lstStyle/>
           <a:p>
-            <a:pPr algn="l" indent="0" marL="0">
+            <a:pPr marL="0" indent="0" algn="l">
               <a:lnSpc>
                 <a:spcPts val="2100"/>
               </a:lnSpc>
@@ -15393,7 +15635,7 @@
           </a:bodyPr>
           <a:lstStyle/>
           <a:p>
-            <a:pPr algn="l" indent="0" marL="0">
+            <a:pPr marL="0" indent="0" algn="l">
               <a:lnSpc>
                 <a:spcPts val="2100"/>
               </a:lnSpc>
@@ -15439,7 +15681,7 @@
           </a:bodyPr>
           <a:lstStyle/>
           <a:p>
-            <a:pPr algn="l" indent="0" marL="0">
+            <a:pPr marL="0" indent="0" algn="l">
               <a:lnSpc>
                 <a:spcPts val="2100"/>
               </a:lnSpc>
@@ -15483,7 +15725,7 @@
           </a:bodyPr>
           <a:lstStyle/>
           <a:p>
-            <a:pPr algn="l" indent="0" marL="0">
+            <a:pPr marL="0" indent="0" algn="l">
               <a:lnSpc>
                 <a:spcPts val="1680"/>
               </a:lnSpc>
@@ -15527,7 +15769,7 @@
           </a:bodyPr>
           <a:lstStyle/>
           <a:p>
-            <a:pPr algn="r" indent="0" marL="0">
+            <a:pPr marL="0" indent="0" algn="r">
               <a:lnSpc>
                 <a:spcPts val="1680"/>
               </a:lnSpc>
@@ -15844,4 +16086,319 @@
   <a:objectDefaults/>
   <a:extraClrSchemeLst/>
 </a:theme>
+</file>
+
+<file path=ppt/theme/theme2.xml><?xml version="1.0" encoding="utf-8"?>
+<a:theme xmlns:a="http://schemas.openxmlformats.org/drawingml/2006/main" name="Tema de Office">
+  <a:themeElements>
+    <a:clrScheme name="Office">
+      <a:dk1>
+        <a:sysClr val="windowText" lastClr="000000"/>
+      </a:dk1>
+      <a:lt1>
+        <a:sysClr val="window" lastClr="FFFFFF"/>
+      </a:lt1>
+      <a:dk2>
+        <a:srgbClr val="0E2841"/>
+      </a:dk2>
+      <a:lt2>
+        <a:srgbClr val="E8E8E8"/>
+      </a:lt2>
+      <a:accent1>
+        <a:srgbClr val="156082"/>
+      </a:accent1>
+      <a:accent2>
+        <a:srgbClr val="E97132"/>
+      </a:accent2>
+      <a:accent3>
+        <a:srgbClr val="196B24"/>
+      </a:accent3>
+      <a:accent4>
+        <a:srgbClr val="0F9ED5"/>
+      </a:accent4>
+      <a:accent5>
+        <a:srgbClr val="A02B93"/>
+      </a:accent5>
+      <a:accent6>
+        <a:srgbClr val="4EA72E"/>
+      </a:accent6>
+      <a:hlink>
+        <a:srgbClr val="467886"/>
+      </a:hlink>
+      <a:folHlink>
+        <a:srgbClr val="96607D"/>
+      </a:folHlink>
+    </a:clrScheme>
+    <a:fontScheme name="Office">
+      <a:majorFont>
+        <a:latin typeface="Aptos Display" panose="02110004020202020204"/>
+        <a:ea typeface=""/>
+        <a:cs typeface=""/>
+        <a:font script="Jpan" typeface="游ゴシック Light"/>
+        <a:font script="Hang" typeface="맑은 고딕"/>
+        <a:font script="Hans" typeface="等线 Light"/>
+        <a:font script="Hant" typeface="新細明體"/>
+        <a:font script="Arab" typeface="Times New Roman"/>
+        <a:font script="Hebr" typeface="Times New Roman"/>
+        <a:font script="Thai" typeface="Angsana New"/>
+        <a:font script="Ethi" typeface="Nyala"/>
+        <a:font script="Beng" typeface="Vrinda"/>
+        <a:font script="Gujr" typeface="Shruti"/>
+        <a:font script="Khmr" typeface="MoolBoran"/>
+        <a:font script="Knda" typeface="Tunga"/>
+        <a:font script="Guru" typeface="Raavi"/>
+        <a:font script="Cans" typeface="Euphemia"/>
+        <a:font script="Cher" typeface="Plantagenet Cherokee"/>
+        <a:font script="Yiii" typeface="Microsoft Yi Baiti"/>
+        <a:font script="Tibt" typeface="Microsoft Himalaya"/>
+        <a:font script="Thaa" typeface="MV Boli"/>
+        <a:font script="Deva" typeface="Mangal"/>
+        <a:font script="Telu" typeface="Gautami"/>
+        <a:font script="Taml" typeface="Latha"/>
+        <a:font script="Syrc" typeface="Estrangelo Edessa"/>
+        <a:font script="Orya" typeface="Kalinga"/>
+        <a:font script="Mlym" typeface="Kartika"/>
+        <a:font script="Laoo" typeface="DokChampa"/>
+        <a:font script="Sinh" typeface="Iskoola Pota"/>
+        <a:font script="Mong" typeface="Mongolian Baiti"/>
+        <a:font script="Viet" typeface="Times New Roman"/>
+        <a:font script="Uigh" typeface="Microsoft Uighur"/>
+        <a:font script="Geor" typeface="Sylfaen"/>
+        <a:font script="Armn" typeface="Arial"/>
+        <a:font script="Bugi" typeface="Leelawadee UI"/>
+        <a:font script="Bopo" typeface="Microsoft JhengHei"/>
+        <a:font script="Java" typeface="Javanese Text"/>
+        <a:font script="Lisu" typeface="Segoe UI"/>
+        <a:font script="Mymr" typeface="Myanmar Text"/>
+        <a:font script="Nkoo" typeface="Ebrima"/>
+        <a:font script="Olck" typeface="Nirmala UI"/>
+        <a:font script="Osma" typeface="Ebrima"/>
+        <a:font script="Phag" typeface="Phagspa"/>
+        <a:font script="Syrn" typeface="Estrangelo Edessa"/>
+        <a:font script="Syrj" typeface="Estrangelo Edessa"/>
+        <a:font script="Syre" typeface="Estrangelo Edessa"/>
+        <a:font script="Sora" typeface="Nirmala UI"/>
+        <a:font script="Tale" typeface="Microsoft Tai Le"/>
+        <a:font script="Talu" typeface="Microsoft New Tai Lue"/>
+        <a:font script="Tfng" typeface="Ebrima"/>
+      </a:majorFont>
+      <a:minorFont>
+        <a:latin typeface="Aptos" panose="02110004020202020204"/>
+        <a:ea typeface=""/>
+        <a:cs typeface=""/>
+        <a:font script="Jpan" typeface="游ゴシック"/>
+        <a:font script="Hang" typeface="맑은 고딕"/>
+        <a:font script="Hans" typeface="等线"/>
+        <a:font script="Hant" typeface="新細明體"/>
+        <a:font script="Arab" typeface="Arial"/>
+        <a:font script="Hebr" typeface="Arial"/>
+        <a:font script="Thai" typeface="Cordia New"/>
+        <a:font script="Ethi" typeface="Nyala"/>
+        <a:font script="Beng" typeface="Vrinda"/>
+        <a:font script="Gujr" typeface="Shruti"/>
+        <a:font script="Khmr" typeface="DaunPenh"/>
+        <a:font script="Knda" typeface="Tunga"/>
+        <a:font script="Guru" typeface="Raavi"/>
+        <a:font script="Cans" typeface="Euphemia"/>
+        <a:font script="Cher" typeface="Plantagenet Cherokee"/>
+        <a:font script="Yiii" typeface="Microsoft Yi Baiti"/>
+        <a:font script="Tibt" typeface="Microsoft Himalaya"/>
+        <a:font script="Thaa" typeface="MV Boli"/>
+        <a:font script="Deva" typeface="Mangal"/>
+        <a:font script="Telu" typeface="Gautami"/>
+        <a:font script="Taml" typeface="Latha"/>
+        <a:font script="Syrc" typeface="Estrangelo Edessa"/>
+        <a:font script="Orya" typeface="Kalinga"/>
+        <a:font script="Mlym" typeface="Kartika"/>
+        <a:font script="Laoo" typeface="DokChampa"/>
+        <a:font script="Sinh" typeface="Iskoola Pota"/>
+        <a:font script="Mong" typeface="Mongolian Baiti"/>
+        <a:font script="Viet" typeface="Arial"/>
+        <a:font script="Uigh" typeface="Microsoft Uighur"/>
+        <a:font script="Geor" typeface="Sylfaen"/>
+        <a:font script="Armn" typeface="Arial"/>
+        <a:font script="Bugi" typeface="Leelawadee UI"/>
+        <a:font script="Bopo" typeface="Microsoft JhengHei"/>
+        <a:font script="Java" typeface="Javanese Text"/>
+        <a:font script="Lisu" typeface="Segoe UI"/>
+        <a:font script="Mymr" typeface="Myanmar Text"/>
+        <a:font script="Nkoo" typeface="Ebrima"/>
+        <a:font script="Olck" typeface="Nirmala UI"/>
+        <a:font script="Osma" typeface="Ebrima"/>
+        <a:font script="Phag" typeface="Phagspa"/>
+        <a:font script="Syrn" typeface="Estrangelo Edessa"/>
+        <a:font script="Syrj" typeface="Estrangelo Edessa"/>
+        <a:font script="Syre" typeface="Estrangelo Edessa"/>
+        <a:font script="Sora" typeface="Nirmala UI"/>
+        <a:font script="Tale" typeface="Microsoft Tai Le"/>
+        <a:font script="Talu" typeface="Microsoft New Tai Lue"/>
+        <a:font script="Tfng" typeface="Ebrima"/>
+      </a:minorFont>
+    </a:fontScheme>
+    <a:fmtScheme name="Office">
+      <a:fillStyleLst>
+        <a:solidFill>
+          <a:schemeClr val="phClr"/>
+        </a:solidFill>
+        <a:gradFill rotWithShape="1">
+          <a:gsLst>
+            <a:gs pos="0">
+              <a:schemeClr val="phClr">
+                <a:lumMod val="110000"/>
+                <a:satMod val="105000"/>
+                <a:tint val="67000"/>
+              </a:schemeClr>
+            </a:gs>
+            <a:gs pos="50000">
+              <a:schemeClr val="phClr">
+                <a:lumMod val="105000"/>
+                <a:satMod val="103000"/>
+                <a:tint val="73000"/>
+              </a:schemeClr>
+            </a:gs>
+            <a:gs pos="100000">
+              <a:schemeClr val="phClr">
+                <a:lumMod val="105000"/>
+                <a:satMod val="109000"/>
+                <a:tint val="81000"/>
+              </a:schemeClr>
+            </a:gs>
+          </a:gsLst>
+          <a:lin ang="5400000" scaled="0"/>
+        </a:gradFill>
+        <a:gradFill rotWithShape="1">
+          <a:gsLst>
+            <a:gs pos="0">
+              <a:schemeClr val="phClr">
+                <a:satMod val="103000"/>
+                <a:lumMod val="102000"/>
+                <a:tint val="94000"/>
+              </a:schemeClr>
+            </a:gs>
+            <a:gs pos="50000">
+              <a:schemeClr val="phClr">
+                <a:satMod val="110000"/>
+                <a:lumMod val="100000"/>
+                <a:shade val="100000"/>
+              </a:schemeClr>
+            </a:gs>
+            <a:gs pos="100000">
+              <a:schemeClr val="phClr">
+                <a:lumMod val="99000"/>
+                <a:satMod val="120000"/>
+                <a:shade val="78000"/>
+              </a:schemeClr>
+            </a:gs>
+          </a:gsLst>
+          <a:lin ang="5400000" scaled="0"/>
+        </a:gradFill>
+      </a:fillStyleLst>
+      <a:lnStyleLst>
+        <a:ln w="12700" cap="flat" cmpd="sng" algn="ctr">
+          <a:solidFill>
+            <a:schemeClr val="phClr"/>
+          </a:solidFill>
+          <a:prstDash val="solid"/>
+          <a:miter lim="800000"/>
+        </a:ln>
+        <a:ln w="19050" cap="flat" cmpd="sng" algn="ctr">
+          <a:solidFill>
+            <a:schemeClr val="phClr"/>
+          </a:solidFill>
+          <a:prstDash val="solid"/>
+          <a:miter lim="800000"/>
+        </a:ln>
+        <a:ln w="25400" cap="flat" cmpd="sng" algn="ctr">
+          <a:solidFill>
+            <a:schemeClr val="phClr"/>
+          </a:solidFill>
+          <a:prstDash val="solid"/>
+          <a:miter lim="800000"/>
+        </a:ln>
+      </a:lnStyleLst>
+      <a:effectStyleLst>
+        <a:effectStyle>
+          <a:effectLst/>
+        </a:effectStyle>
+        <a:effectStyle>
+          <a:effectLst/>
+        </a:effectStyle>
+        <a:effectStyle>
+          <a:effectLst>
+            <a:outerShdw blurRad="57150" dist="19050" dir="5400000" algn="ctr" rotWithShape="0">
+              <a:srgbClr val="000000">
+                <a:alpha val="63000"/>
+              </a:srgbClr>
+            </a:outerShdw>
+          </a:effectLst>
+        </a:effectStyle>
+      </a:effectStyleLst>
+      <a:bgFillStyleLst>
+        <a:solidFill>
+          <a:schemeClr val="phClr"/>
+        </a:solidFill>
+        <a:solidFill>
+          <a:schemeClr val="phClr">
+            <a:tint val="95000"/>
+            <a:satMod val="170000"/>
+          </a:schemeClr>
+        </a:solidFill>
+        <a:gradFill rotWithShape="1">
+          <a:gsLst>
+            <a:gs pos="0">
+              <a:schemeClr val="phClr">
+                <a:tint val="93000"/>
+                <a:satMod val="150000"/>
+                <a:shade val="98000"/>
+                <a:lumMod val="102000"/>
+              </a:schemeClr>
+            </a:gs>
+            <a:gs pos="50000">
+              <a:schemeClr val="phClr">
+                <a:tint val="98000"/>
+                <a:satMod val="130000"/>
+                <a:shade val="90000"/>
+                <a:lumMod val="103000"/>
+              </a:schemeClr>
+            </a:gs>
+            <a:gs pos="100000">
+              <a:schemeClr val="phClr">
+                <a:shade val="63000"/>
+                <a:satMod val="120000"/>
+              </a:schemeClr>
+            </a:gs>
+          </a:gsLst>
+          <a:lin ang="5400000" scaled="0"/>
+        </a:gradFill>
+      </a:bgFillStyleLst>
+    </a:fmtScheme>
+  </a:themeElements>
+  <a:objectDefaults>
+    <a:lnDef>
+      <a:spPr/>
+      <a:bodyPr/>
+      <a:lstStyle/>
+      <a:style>
+        <a:lnRef idx="2">
+          <a:schemeClr val="accent1"/>
+        </a:lnRef>
+        <a:fillRef idx="0">
+          <a:schemeClr val="accent1"/>
+        </a:fillRef>
+        <a:effectRef idx="1">
+          <a:schemeClr val="accent1"/>
+        </a:effectRef>
+        <a:fontRef idx="minor">
+          <a:schemeClr val="tx1"/>
+        </a:fontRef>
+      </a:style>
+    </a:lnDef>
+  </a:objectDefaults>
+  <a:extraClrSchemeLst/>
+  <a:extLst>
+    <a:ext uri="{05A4C25C-085E-4340-85A3-A5531E510DB2}">
+      <thm15:themeFamily xmlns:thm15="http://schemas.microsoft.com/office/thememl/2012/main" name="Office Theme" id="{2E142A2C-CD16-42D6-873A-C26D2A0506FA}" vid="{1BDDFF52-6CD6-40A5-AB3C-68EB2F1E4D0A}"/>
+    </a:ext>
+  </a:extLst>
+</a:theme>
 </file>
</xml_diff>